<commit_message>
docs: prominently feature IDMC (12 cloud services) across all documentation
- README: title, hero description, badge, Supported Sources table (new IDMC row),
  new IDMC box in What Gets Migrated section
- MIGRATION_PLAN: title, description, executive summary, component mapping table (IDMC row)
- GAP_ANALYSIS: IDMC badge, scope line updated
- ENTERPRISE_PLAYBOOK: executive summary mentions all 12 IDMC services
- USER_GUIDE: title, prerequisites (IDMC credentials)
- AGENTS: assessment agent Quick Reference, Role, Inputs, Outputs (IDMC)
- CONTRIBUTING: status line (multi-source: PowerCenter, IICS, IDMC)
- PPTX: title slide, problem slide (IDMC complexity), solution slide (IDMC in features)
- PPTX regenerated: 16 slides with IDMC throughout
</commit_message>
<xml_diff>
--- a/output/Informatica_to_Fabric_Migration_Tool.pptx
+++ b/output/Informatica_to_Fabric_Migration_Tool.pptx
@@ -3140,7 +3140,7 @@
                   <a:srgbClr val="FFFFFF"/>
                 </a:solidFill>
               </a:rPr>
-              <a:t>Informatica  →  Microsoft Fabric / Azure Databricks</a:t>
+              <a:t>Informatica PowerCenter / IDMC  →  Microsoft Fabric / Azure Databricks</a:t>
             </a:r>
           </a:p>
         </p:txBody>
@@ -3174,7 +3174,7 @@
                   <a:srgbClr val="BDC3C7"/>
                 </a:solidFill>
               </a:rPr>
-              <a:t>Automated Migration Tool — Functionality Overview &amp; ROI Analysis</a:t>
+              <a:t>Automated Migration Tool — PowerCenter + IICS + IDMC (12 Services) → Fabric / Databricks / DBT</a:t>
             </a:r>
           </a:p>
         </p:txBody>
@@ -14339,7 +14339,7 @@
                   <a:srgbClr val="2C3E50"/>
                 </a:solidFill>
               </a:rPr>
-              <a:t>▸  Informatica PowerCenter/IICS licensing costs escalate year-over-year (avg. 15-25% annual increase)</a:t>
+              <a:t>▸  Informatica PowerCenter/IICS/IDMC licensing costs escalate year-over-year (avg. 15-25% annual increase)</a:t>
             </a:r>
           </a:p>
           <a:p>
@@ -14370,6 +14370,21 @@
                 </a:solidFill>
               </a:rPr>
               <a:t>▸  Vendor lock-in: proprietary XML formats, no native cloud integration, limited Spark support</a:t>
+            </a:r>
+          </a:p>
+          <a:p>
+            <a:pPr>
+              <a:spcAft>
+                <a:spcPts val="600"/>
+              </a:spcAft>
+            </a:pPr>
+            <a:r>
+              <a:rPr sz="1600">
+                <a:solidFill>
+                  <a:srgbClr val="2C3E50"/>
+                </a:solidFill>
+              </a:rPr>
+              <a:t>▸  IDMC cloud services (CDI, CDGC, CDQ, MDM, etc.) add complexity without reducing on-prem footprint</a:t>
             </a:r>
           </a:p>
           <a:p>
@@ -15282,7 +15297,7 @@
                   <a:srgbClr val="2C3E50"/>
                 </a:solidFill>
               </a:rPr>
-              <a:t>▸  PowerCenter 9.x/10.x + IICS full support</a:t>
+              <a:t>▸  PowerCenter 9.x/10.x + IICS + IDMC (12 cloud services) full support</a:t>
             </a:r>
           </a:p>
           <a:p>

</xml_diff>

<commit_message>
chore: simplify functionality slide to 'What Gets Generated' artifact grid
</commit_message>
<xml_diff>
--- a/output/Informatica_to_Fabric_Migration_Tool.pptx
+++ b/output/Informatica_to_Fabric_Migration_Tool.pptx
@@ -5239,7 +5239,7 @@
                   <a:srgbClr val="FFFFFF"/>
                 </a:solidFill>
               </a:rPr>
-              <a:t>Functionality Coverage</a:t>
+              <a:t>What Gets Generated</a:t>
             </a:r>
           </a:p>
         </p:txBody>
@@ -5273,7 +5273,7 @@
                   <a:srgbClr val="BDC3C7"/>
                 </a:solidFill>
               </a:rPr>
-              <a:t>100 sprints  •  17 phases  •  2,143 tests  •  9 agents  •  4 target platforms</a:t>
+              <a:t>One command → all artifacts, ready for Fabric / Databricks / DBT</a:t>
             </a:r>
           </a:p>
         </p:txBody>
@@ -5286,47 +5286,39 @@
         </p:nvSpPr>
         <p:spPr>
           <a:xfrm>
-            <a:off x="320040" y="1325880"/>
-            <a:ext cx="3657600" cy="384048"/>
-          </a:xfrm>
-          <a:prstGeom prst="roundRect">
-            <a:avLst/>
-          </a:prstGeom>
-          <a:solidFill>
-            <a:srgbClr val="0078D4"/>
-          </a:solidFill>
-          <a:ln>
-            <a:noFill/>
-          </a:ln>
-          <a:effectLst/>
-        </p:spPr>
-        <p:style>
-          <a:lnRef idx="1">
-            <a:schemeClr val="accent1"/>
-          </a:lnRef>
-          <a:fillRef idx="3">
-            <a:schemeClr val="accent1"/>
-          </a:fillRef>
-          <a:effectRef idx="2">
-            <a:schemeClr val="accent1"/>
-          </a:effectRef>
-          <a:fontRef idx="minor">
-            <a:schemeClr val="lt1"/>
-          </a:fontRef>
-        </p:style>
-        <p:txBody>
-          <a:bodyPr rtlCol="0" anchor="ctr" wrap="square"/>
-          <a:lstStyle/>
-          <a:p>
-            <a:pPr algn="l"/>
-            <a:r>
-              <a:rPr sz="1200" b="1">
-                <a:solidFill>
-                  <a:srgbClr val="FFFFFF"/>
-                </a:solidFill>
-              </a:rPr>
-              <a:t>🔄 Migration Engine</a:t>
-            </a:r>
+            <a:off x="274320" y="1417320"/>
+            <a:ext cx="109728" cy="640080"/>
+          </a:xfrm>
+          <a:prstGeom prst="roundRect">
+            <a:avLst/>
+          </a:prstGeom>
+          <a:solidFill>
+            <a:srgbClr val="27AE60"/>
+          </a:solidFill>
+          <a:ln>
+            <a:noFill/>
+          </a:ln>
+          <a:effectLst/>
+        </p:spPr>
+        <p:style>
+          <a:lnRef idx="1">
+            <a:schemeClr val="accent1"/>
+          </a:lnRef>
+          <a:fillRef idx="3">
+            <a:schemeClr val="accent1"/>
+          </a:fillRef>
+          <a:effectRef idx="2">
+            <a:schemeClr val="accent1"/>
+          </a:effectRef>
+          <a:fontRef idx="minor">
+            <a:schemeClr val="lt1"/>
+          </a:fontRef>
+        </p:style>
+        <p:txBody>
+          <a:bodyPr rtlCol="0" anchor="ctr"/>
+          <a:lstStyle/>
+          <a:p>
+            <a:pPr algn="ctr"/>
           </a:p>
         </p:txBody>
       </p:sp>
@@ -5338,8 +5330,8 @@
         </p:nvSpPr>
         <p:spPr>
           <a:xfrm>
-            <a:off x="393192" y="1728216"/>
-            <a:ext cx="3511296" cy="1133856"/>
+            <a:off x="438912" y="1417320"/>
+            <a:ext cx="2651760" cy="347472"/>
           </a:xfrm>
           <a:prstGeom prst="rect">
             <a:avLst/>
@@ -5352,144 +5344,28 @@
           </a:bodyPr>
           <a:lstStyle/>
           <a:p>
-            <a:pPr>
-              <a:spcAft>
-                <a:spcPts val="200"/>
-              </a:spcAft>
-            </a:pPr>
-            <a:r>
-              <a:rPr sz="1000">
-                <a:solidFill>
-                  <a:srgbClr val="2C3E50"/>
-                </a:solidFill>
-              </a:rPr>
-              <a:t>▸  26+ transformation types</a:t>
-            </a:r>
-          </a:p>
-          <a:p>
-            <a:pPr>
-              <a:spcAft>
-                <a:spcPts val="200"/>
-              </a:spcAft>
-            </a:pPr>
-            <a:r>
-              <a:rPr sz="1000">
-                <a:solidFill>
-                  <a:srgbClr val="2C3E50"/>
-                </a:solidFill>
-              </a:rPr>
-              <a:t>▸  6 source databases</a:t>
-            </a:r>
-          </a:p>
-          <a:p>
-            <a:pPr>
-              <a:spcAft>
-                <a:spcPts val="200"/>
-              </a:spcAft>
-            </a:pPr>
-            <a:r>
-              <a:rPr sz="1000">
-                <a:solidFill>
-                  <a:srgbClr val="2C3E50"/>
-                </a:solidFill>
-              </a:rPr>
-              <a:t>▸  180+ SQL patterns</a:t>
-            </a:r>
-          </a:p>
-          <a:p>
-            <a:pPr>
-              <a:spcAft>
-                <a:spcPts val="200"/>
-              </a:spcAft>
-            </a:pPr>
-            <a:r>
-              <a:rPr sz="1000">
-                <a:solidFill>
-                  <a:srgbClr val="2C3E50"/>
-                </a:solidFill>
-              </a:rPr>
-              <a:t>▸  AutoSys JIL conversion</a:t>
-            </a:r>
-          </a:p>
-          <a:p>
-            <a:pPr>
-              <a:spcAft>
-                <a:spcPts val="200"/>
-              </a:spcAft>
-            </a:pPr>
-            <a:r>
-              <a:rPr sz="1000">
-                <a:solidFill>
-                  <a:srgbClr val="2C3E50"/>
-                </a:solidFill>
-              </a:rPr>
-              <a:t>▸  IICS + IDMC (12 services)</a:t>
-            </a:r>
-          </a:p>
-        </p:txBody>
-      </p:sp>
-      <p:sp>
-        <p:nvSpPr>
-          <p:cNvPr id="7" name="Rounded Rectangle 6"/>
-          <p:cNvSpPr/>
-          <p:nvPr/>
-        </p:nvSpPr>
-        <p:spPr>
-          <a:xfrm>
-            <a:off x="4206240" y="1325880"/>
-            <a:ext cx="3657600" cy="384048"/>
-          </a:xfrm>
-          <a:prstGeom prst="roundRect">
-            <a:avLst/>
-          </a:prstGeom>
-          <a:solidFill>
-            <a:srgbClr val="8E44AD"/>
-          </a:solidFill>
-          <a:ln>
-            <a:noFill/>
-          </a:ln>
-          <a:effectLst/>
-        </p:spPr>
-        <p:style>
-          <a:lnRef idx="1">
-            <a:schemeClr val="accent1"/>
-          </a:lnRef>
-          <a:fillRef idx="3">
-            <a:schemeClr val="accent1"/>
-          </a:fillRef>
-          <a:effectRef idx="2">
-            <a:schemeClr val="accent1"/>
-          </a:effectRef>
-          <a:fontRef idx="minor">
-            <a:schemeClr val="lt1"/>
-          </a:fontRef>
-        </p:style>
-        <p:txBody>
-          <a:bodyPr rtlCol="0" anchor="ctr" wrap="square"/>
-          <a:lstStyle/>
-          <a:p>
             <a:pPr algn="l"/>
             <a:r>
-              <a:rPr sz="1200" b="1">
-                <a:solidFill>
-                  <a:srgbClr val="FFFFFF"/>
-                </a:solidFill>
-              </a:rPr>
-              <a:t>🤖 AI &amp; Intelligence</a:t>
-            </a:r>
-          </a:p>
-        </p:txBody>
-      </p:sp>
-      <p:sp>
-        <p:nvSpPr>
-          <p:cNvPr id="8" name="TextBox 7"/>
+              <a:rPr sz="1300" b="1">
+                <a:solidFill>
+                  <a:srgbClr val="003C6E"/>
+                </a:solidFill>
+              </a:rPr>
+              <a:t>📓  PySpark Notebooks</a:t>
+            </a:r>
+          </a:p>
+        </p:txBody>
+      </p:sp>
+      <p:sp>
+        <p:nvSpPr>
+          <p:cNvPr id="7" name="TextBox 6"/>
           <p:cNvSpPr txBox="1"/>
           <p:nvPr/>
         </p:nvSpPr>
         <p:spPr>
           <a:xfrm>
-            <a:off x="4279392" y="1728216"/>
-            <a:ext cx="3511296" cy="1133856"/>
+            <a:off x="438912" y="1737360"/>
+            <a:ext cx="2651760" cy="320040"/>
           </a:xfrm>
           <a:prstGeom prst="rect">
             <a:avLst/>
@@ -5502,144 +5378,72 @@
           </a:bodyPr>
           <a:lstStyle/>
           <a:p>
-            <a:pPr>
-              <a:spcAft>
-                <a:spcPts val="200"/>
-              </a:spcAft>
-            </a:pPr>
-            <a:r>
-              <a:rPr sz="1000">
-                <a:solidFill>
-                  <a:srgbClr val="2C3E50"/>
-                </a:solidFill>
-              </a:rPr>
-              <a:t>▸  LLM-powered SQL conversion</a:t>
-            </a:r>
-          </a:p>
-          <a:p>
-            <a:pPr>
-              <a:spcAft>
-                <a:spcPts val="200"/>
-              </a:spcAft>
-            </a:pPr>
-            <a:r>
-              <a:rPr sz="1000">
-                <a:solidFill>
-                  <a:srgbClr val="2C3E50"/>
-                </a:solidFill>
-              </a:rPr>
-              <a:t>▸  Confidence scoring</a:t>
-            </a:r>
-          </a:p>
-          <a:p>
-            <a:pPr>
-              <a:spcAft>
-                <a:spcPts val="200"/>
-              </a:spcAft>
-            </a:pPr>
-            <a:r>
-              <a:rPr sz="1000">
-                <a:solidFill>
-                  <a:srgbClr val="2C3E50"/>
-                </a:solidFill>
-              </a:rPr>
-              <a:t>▸  Pattern learning</a:t>
-            </a:r>
-          </a:p>
-          <a:p>
-            <a:pPr>
-              <a:spcAft>
-                <a:spcPts val="200"/>
-              </a:spcAft>
-            </a:pPr>
-            <a:r>
-              <a:rPr sz="1000">
-                <a:solidFill>
-                  <a:srgbClr val="2C3E50"/>
-                </a:solidFill>
-              </a:rPr>
-              <a:t>▸  Chat-based assistant</a:t>
-            </a:r>
-          </a:p>
-          <a:p>
-            <a:pPr>
-              <a:spcAft>
-                <a:spcPts val="200"/>
-              </a:spcAft>
-            </a:pPr>
-            <a:r>
-              <a:rPr sz="1000">
-                <a:solidFill>
-                  <a:srgbClr val="2C3E50"/>
-                </a:solidFill>
-              </a:rPr>
-              <a:t>▸  Gap resolution</a:t>
-            </a:r>
-          </a:p>
-        </p:txBody>
-      </p:sp>
-      <p:sp>
-        <p:nvSpPr>
-          <p:cNvPr id="9" name="Rounded Rectangle 8"/>
-          <p:cNvSpPr/>
-          <p:nvPr/>
-        </p:nvSpPr>
-        <p:spPr>
-          <a:xfrm>
-            <a:off x="8092440" y="1325880"/>
-            <a:ext cx="3657600" cy="384048"/>
-          </a:xfrm>
-          <a:prstGeom prst="roundRect">
-            <a:avLst/>
-          </a:prstGeom>
-          <a:solidFill>
-            <a:srgbClr val="E74C3C"/>
-          </a:solidFill>
-          <a:ln>
-            <a:noFill/>
-          </a:ln>
-          <a:effectLst/>
-        </p:spPr>
-        <p:style>
-          <a:lnRef idx="1">
-            <a:schemeClr val="accent1"/>
-          </a:lnRef>
-          <a:fillRef idx="3">
-            <a:schemeClr val="accent1"/>
-          </a:fillRef>
-          <a:effectRef idx="2">
-            <a:schemeClr val="accent1"/>
-          </a:effectRef>
-          <a:fontRef idx="minor">
-            <a:schemeClr val="lt1"/>
-          </a:fontRef>
-        </p:style>
-        <p:txBody>
-          <a:bodyPr rtlCol="0" anchor="ctr" wrap="square"/>
-          <a:lstStyle/>
-          <a:p>
             <a:pPr algn="l"/>
             <a:r>
-              <a:rPr sz="1200" b="1">
-                <a:solidFill>
-                  <a:srgbClr val="FFFFFF"/>
-                </a:solidFill>
-              </a:rPr>
-              <a:t>🌊 CDC &amp; Streaming</a:t>
-            </a:r>
-          </a:p>
-        </p:txBody>
-      </p:sp>
-      <p:sp>
-        <p:nvSpPr>
-          <p:cNvPr id="10" name="TextBox 9"/>
+              <a:rPr sz="1100" b="0">
+                <a:solidFill>
+                  <a:srgbClr val="2C3E50"/>
+                </a:solidFill>
+              </a:rPr>
+              <a:t>NB_*.py</a:t>
+            </a:r>
+          </a:p>
+        </p:txBody>
+      </p:sp>
+      <p:sp>
+        <p:nvSpPr>
+          <p:cNvPr id="8" name="Rounded Rectangle 7"/>
+          <p:cNvSpPr/>
+          <p:nvPr/>
+        </p:nvSpPr>
+        <p:spPr>
+          <a:xfrm>
+            <a:off x="274320" y="2331720"/>
+            <a:ext cx="109728" cy="640080"/>
+          </a:xfrm>
+          <a:prstGeom prst="roundRect">
+            <a:avLst/>
+          </a:prstGeom>
+          <a:solidFill>
+            <a:srgbClr val="8E44AD"/>
+          </a:solidFill>
+          <a:ln>
+            <a:noFill/>
+          </a:ln>
+          <a:effectLst/>
+        </p:spPr>
+        <p:style>
+          <a:lnRef idx="1">
+            <a:schemeClr val="accent1"/>
+          </a:lnRef>
+          <a:fillRef idx="3">
+            <a:schemeClr val="accent1"/>
+          </a:fillRef>
+          <a:effectRef idx="2">
+            <a:schemeClr val="accent1"/>
+          </a:effectRef>
+          <a:fontRef idx="minor">
+            <a:schemeClr val="lt1"/>
+          </a:fontRef>
+        </p:style>
+        <p:txBody>
+          <a:bodyPr rtlCol="0" anchor="ctr"/>
+          <a:lstStyle/>
+          <a:p>
+            <a:pPr algn="ctr"/>
+          </a:p>
+        </p:txBody>
+      </p:sp>
+      <p:sp>
+        <p:nvSpPr>
+          <p:cNvPr id="9" name="TextBox 8"/>
           <p:cNvSpPr txBox="1"/>
           <p:nvPr/>
         </p:nvSpPr>
         <p:spPr>
           <a:xfrm>
-            <a:off x="8165592" y="1728216"/>
-            <a:ext cx="3511296" cy="1133856"/>
+            <a:off x="438912" y="2331720"/>
+            <a:ext cx="2651760" cy="347472"/>
           </a:xfrm>
           <a:prstGeom prst="rect">
             <a:avLst/>
@@ -5652,144 +5456,28 @@
           </a:bodyPr>
           <a:lstStyle/>
           <a:p>
-            <a:pPr>
-              <a:spcAft>
-                <a:spcPts val="200"/>
-              </a:spcAft>
-            </a:pPr>
-            <a:r>
-              <a:rPr sz="1000">
-                <a:solidFill>
-                  <a:srgbClr val="2C3E50"/>
-                </a:solidFill>
-              </a:rPr>
-              <a:t>▸  Structured Streaming</a:t>
-            </a:r>
-          </a:p>
-          <a:p>
-            <a:pPr>
-              <a:spcAft>
-                <a:spcPts val="200"/>
-              </a:spcAft>
-            </a:pPr>
-            <a:r>
-              <a:rPr sz="1000">
-                <a:solidFill>
-                  <a:srgbClr val="2C3E50"/>
-                </a:solidFill>
-              </a:rPr>
-              <a:t>▸  Azure Functions (7 triggers)</a:t>
-            </a:r>
-          </a:p>
-          <a:p>
-            <a:pPr>
-              <a:spcAft>
-                <a:spcPts val="200"/>
-              </a:spcAft>
-            </a:pPr>
-            <a:r>
-              <a:rPr sz="1000">
-                <a:solidFill>
-                  <a:srgbClr val="2C3E50"/>
-                </a:solidFill>
-              </a:rPr>
-              <a:t>▸  Eventstream definitions</a:t>
-            </a:r>
-          </a:p>
-          <a:p>
-            <a:pPr>
-              <a:spcAft>
-                <a:spcPts val="200"/>
-              </a:spcAft>
-            </a:pPr>
-            <a:r>
-              <a:rPr sz="1000">
-                <a:solidFill>
-                  <a:srgbClr val="2C3E50"/>
-                </a:solidFill>
-              </a:rPr>
-              <a:t>▸  CDC MERGE INTO patterns</a:t>
-            </a:r>
-          </a:p>
-          <a:p>
-            <a:pPr>
-              <a:spcAft>
-                <a:spcPts val="200"/>
-              </a:spcAft>
-            </a:pPr>
-            <a:r>
-              <a:rPr sz="1000">
-                <a:solidFill>
-                  <a:srgbClr val="2C3E50"/>
-                </a:solidFill>
-              </a:rPr>
-              <a:t>▸  Deployment blueprints</a:t>
-            </a:r>
-          </a:p>
-        </p:txBody>
-      </p:sp>
-      <p:sp>
-        <p:nvSpPr>
-          <p:cNvPr id="11" name="Rounded Rectangle 10"/>
-          <p:cNvSpPr/>
-          <p:nvPr/>
-        </p:nvSpPr>
-        <p:spPr>
-          <a:xfrm>
-            <a:off x="320040" y="2990088"/>
-            <a:ext cx="3657600" cy="384048"/>
-          </a:xfrm>
-          <a:prstGeom prst="roundRect">
-            <a:avLst/>
-          </a:prstGeom>
-          <a:solidFill>
-            <a:srgbClr val="F39C12"/>
-          </a:solidFill>
-          <a:ln>
-            <a:noFill/>
-          </a:ln>
-          <a:effectLst/>
-        </p:spPr>
-        <p:style>
-          <a:lnRef idx="1">
-            <a:schemeClr val="accent1"/>
-          </a:lnRef>
-          <a:fillRef idx="3">
-            <a:schemeClr val="accent1"/>
-          </a:fillRef>
-          <a:effectRef idx="2">
-            <a:schemeClr val="accent1"/>
-          </a:effectRef>
-          <a:fontRef idx="minor">
-            <a:schemeClr val="lt1"/>
-          </a:fontRef>
-        </p:style>
-        <p:txBody>
-          <a:bodyPr rtlCol="0" anchor="ctr" wrap="square"/>
-          <a:lstStyle/>
-          <a:p>
             <a:pPr algn="l"/>
             <a:r>
-              <a:rPr sz="1200" b="1">
-                <a:solidFill>
-                  <a:srgbClr val="FFFFFF"/>
-                </a:solidFill>
-              </a:rPr>
-              <a:t>🔒 Governance</a:t>
-            </a:r>
-          </a:p>
-        </p:txBody>
-      </p:sp>
-      <p:sp>
-        <p:nvSpPr>
-          <p:cNvPr id="12" name="TextBox 11"/>
+              <a:rPr sz="1300" b="1">
+                <a:solidFill>
+                  <a:srgbClr val="003C6E"/>
+                </a:solidFill>
+              </a:rPr>
+              <a:t>🗄️  Converted SQL</a:t>
+            </a:r>
+          </a:p>
+        </p:txBody>
+      </p:sp>
+      <p:sp>
+        <p:nvSpPr>
+          <p:cNvPr id="10" name="TextBox 9"/>
           <p:cNvSpPr txBox="1"/>
           <p:nvPr/>
         </p:nvSpPr>
         <p:spPr>
           <a:xfrm>
-            <a:off x="393192" y="3392424"/>
-            <a:ext cx="3511296" cy="1133856"/>
+            <a:off x="438912" y="2651760"/>
+            <a:ext cx="2651760" cy="320040"/>
           </a:xfrm>
           <a:prstGeom prst="rect">
             <a:avLst/>
@@ -5802,144 +5490,72 @@
           </a:bodyPr>
           <a:lstStyle/>
           <a:p>
-            <a:pPr>
-              <a:spcAft>
-                <a:spcPts val="200"/>
-              </a:spcAft>
-            </a:pPr>
-            <a:r>
-              <a:rPr sz="1000">
-                <a:solidFill>
-                  <a:srgbClr val="2C3E50"/>
-                </a:solidFill>
-              </a:rPr>
-              <a:t>▸  RLS / Column masking</a:t>
-            </a:r>
-          </a:p>
-          <a:p>
-            <a:pPr>
-              <a:spcAft>
-                <a:spcPts val="200"/>
-              </a:spcAft>
-            </a:pPr>
-            <a:r>
-              <a:rPr sz="1000">
-                <a:solidFill>
-                  <a:srgbClr val="2C3E50"/>
-                </a:solidFill>
-              </a:rPr>
-              <a:t>▸  GDPR / CCPA compliance</a:t>
-            </a:r>
-          </a:p>
-          <a:p>
-            <a:pPr>
-              <a:spcAft>
-                <a:spcPts val="200"/>
-              </a:spcAft>
-            </a:pPr>
-            <a:r>
-              <a:rPr sz="1000">
-                <a:solidFill>
-                  <a:srgbClr val="2C3E50"/>
-                </a:solidFill>
-              </a:rPr>
-              <a:t>▸  PII classification</a:t>
-            </a:r>
-          </a:p>
-          <a:p>
-            <a:pPr>
-              <a:spcAft>
-                <a:spcPts val="200"/>
-              </a:spcAft>
-            </a:pPr>
-            <a:r>
-              <a:rPr sz="1000">
-                <a:solidFill>
-                  <a:srgbClr val="2C3E50"/>
-                </a:solidFill>
-              </a:rPr>
-              <a:t>▸  6-gate certification</a:t>
-            </a:r>
-          </a:p>
-          <a:p>
-            <a:pPr>
-              <a:spcAft>
-                <a:spcPts val="200"/>
-              </a:spcAft>
-            </a:pPr>
-            <a:r>
-              <a:rPr sz="1000">
-                <a:solidFill>
-                  <a:srgbClr val="2C3E50"/>
-                </a:solidFill>
-              </a:rPr>
-              <a:t>▸  Data residency validation</a:t>
-            </a:r>
-          </a:p>
-        </p:txBody>
-      </p:sp>
-      <p:sp>
-        <p:nvSpPr>
-          <p:cNvPr id="13" name="Rounded Rectangle 12"/>
-          <p:cNvSpPr/>
-          <p:nvPr/>
-        </p:nvSpPr>
-        <p:spPr>
-          <a:xfrm>
-            <a:off x="4206240" y="2990088"/>
-            <a:ext cx="3657600" cy="384048"/>
-          </a:xfrm>
-          <a:prstGeom prst="roundRect">
-            <a:avLst/>
-          </a:prstGeom>
-          <a:solidFill>
-            <a:srgbClr val="632CA6"/>
-          </a:solidFill>
-          <a:ln>
-            <a:noFill/>
-          </a:ln>
-          <a:effectLst/>
-        </p:spPr>
-        <p:style>
-          <a:lnRef idx="1">
-            <a:schemeClr val="accent1"/>
-          </a:lnRef>
-          <a:fillRef idx="3">
-            <a:schemeClr val="accent1"/>
-          </a:fillRef>
-          <a:effectRef idx="2">
-            <a:schemeClr val="accent1"/>
-          </a:effectRef>
-          <a:fontRef idx="minor">
-            <a:schemeClr val="lt1"/>
-          </a:fontRef>
-        </p:style>
-        <p:txBody>
-          <a:bodyPr rtlCol="0" anchor="ctr" wrap="square"/>
-          <a:lstStyle/>
-          <a:p>
             <a:pPr algn="l"/>
             <a:r>
-              <a:rPr sz="1200" b="1">
-                <a:solidFill>
-                  <a:srgbClr val="FFFFFF"/>
-                </a:solidFill>
-              </a:rPr>
-              <a:t>📊 Observability</a:t>
-            </a:r>
-          </a:p>
-        </p:txBody>
-      </p:sp>
-      <p:sp>
-        <p:nvSpPr>
-          <p:cNvPr id="14" name="TextBox 13"/>
+              <a:rPr sz="1100" b="0">
+                <a:solidFill>
+                  <a:srgbClr val="2C3E50"/>
+                </a:solidFill>
+              </a:rPr>
+              <a:t>SQL_*.sql</a:t>
+            </a:r>
+          </a:p>
+        </p:txBody>
+      </p:sp>
+      <p:sp>
+        <p:nvSpPr>
+          <p:cNvPr id="11" name="Rounded Rectangle 10"/>
+          <p:cNvSpPr/>
+          <p:nvPr/>
+        </p:nvSpPr>
+        <p:spPr>
+          <a:xfrm>
+            <a:off x="274320" y="3246120"/>
+            <a:ext cx="109728" cy="640080"/>
+          </a:xfrm>
+          <a:prstGeom prst="roundRect">
+            <a:avLst/>
+          </a:prstGeom>
+          <a:solidFill>
+            <a:srgbClr val="0078D4"/>
+          </a:solidFill>
+          <a:ln>
+            <a:noFill/>
+          </a:ln>
+          <a:effectLst/>
+        </p:spPr>
+        <p:style>
+          <a:lnRef idx="1">
+            <a:schemeClr val="accent1"/>
+          </a:lnRef>
+          <a:fillRef idx="3">
+            <a:schemeClr val="accent1"/>
+          </a:fillRef>
+          <a:effectRef idx="2">
+            <a:schemeClr val="accent1"/>
+          </a:effectRef>
+          <a:fontRef idx="minor">
+            <a:schemeClr val="lt1"/>
+          </a:fontRef>
+        </p:style>
+        <p:txBody>
+          <a:bodyPr rtlCol="0" anchor="ctr"/>
+          <a:lstStyle/>
+          <a:p>
+            <a:pPr algn="ctr"/>
+          </a:p>
+        </p:txBody>
+      </p:sp>
+      <p:sp>
+        <p:nvSpPr>
+          <p:cNvPr id="12" name="TextBox 11"/>
           <p:cNvSpPr txBox="1"/>
           <p:nvPr/>
         </p:nvSpPr>
         <p:spPr>
           <a:xfrm>
-            <a:off x="4279392" y="3392424"/>
-            <a:ext cx="3511296" cy="1133856"/>
+            <a:off x="438912" y="3246120"/>
+            <a:ext cx="2651760" cy="347472"/>
           </a:xfrm>
           <a:prstGeom prst="rect">
             <a:avLst/>
@@ -5952,144 +5568,28 @@
           </a:bodyPr>
           <a:lstStyle/>
           <a:p>
-            <a:pPr>
-              <a:spcAft>
-                <a:spcPts val="200"/>
-              </a:spcAft>
-            </a:pPr>
-            <a:r>
-              <a:rPr sz="1000">
-                <a:solidFill>
-                  <a:srgbClr val="2C3E50"/>
-                </a:solidFill>
-              </a:rPr>
-              <a:t>▸  Datadog integration</a:t>
-            </a:r>
-          </a:p>
-          <a:p>
-            <a:pPr>
-              <a:spcAft>
-                <a:spcPts val="200"/>
-              </a:spcAft>
-            </a:pPr>
-            <a:r>
-              <a:rPr sz="1000">
-                <a:solidFill>
-                  <a:srgbClr val="2C3E50"/>
-                </a:solidFill>
-              </a:rPr>
-              <a:t>▸  Agentic auto-remediation</a:t>
-            </a:r>
-          </a:p>
-          <a:p>
-            <a:pPr>
-              <a:spcAft>
-                <a:spcPts val="200"/>
-              </a:spcAft>
-            </a:pPr>
-            <a:r>
-              <a:rPr sz="1000">
-                <a:solidFill>
-                  <a:srgbClr val="2C3E50"/>
-                </a:solidFill>
-              </a:rPr>
-              <a:t>▸  Global monitoring platform</a:t>
-            </a:r>
-          </a:p>
-          <a:p>
-            <a:pPr>
-              <a:spcAft>
-                <a:spcPts val="200"/>
-              </a:spcAft>
-            </a:pPr>
-            <a:r>
-              <a:rPr sz="1000">
-                <a:solidFill>
-                  <a:srgbClr val="2C3E50"/>
-                </a:solidFill>
-              </a:rPr>
-              <a:t>▸  4-tier escalation chains</a:t>
-            </a:r>
-          </a:p>
-          <a:p>
-            <a:pPr>
-              <a:spcAft>
-                <a:spcPts val="200"/>
-              </a:spcAft>
-            </a:pPr>
-            <a:r>
-              <a:rPr sz="1000">
-                <a:solidFill>
-                  <a:srgbClr val="2C3E50"/>
-                </a:solidFill>
-              </a:rPr>
-              <a:t>▸  SLO tracking</a:t>
-            </a:r>
-          </a:p>
-        </p:txBody>
-      </p:sp>
-      <p:sp>
-        <p:nvSpPr>
-          <p:cNvPr id="15" name="Rounded Rectangle 14"/>
-          <p:cNvSpPr/>
-          <p:nvPr/>
-        </p:nvSpPr>
-        <p:spPr>
-          <a:xfrm>
-            <a:off x="8092440" y="2990088"/>
-            <a:ext cx="3657600" cy="384048"/>
-          </a:xfrm>
-          <a:prstGeom prst="roundRect">
-            <a:avLst/>
-          </a:prstGeom>
-          <a:solidFill>
-            <a:srgbClr val="27AE60"/>
-          </a:solidFill>
-          <a:ln>
-            <a:noFill/>
-          </a:ln>
-          <a:effectLst/>
-        </p:spPr>
-        <p:style>
-          <a:lnRef idx="1">
-            <a:schemeClr val="accent1"/>
-          </a:lnRef>
-          <a:fillRef idx="3">
-            <a:schemeClr val="accent1"/>
-          </a:fillRef>
-          <a:effectRef idx="2">
-            <a:schemeClr val="accent1"/>
-          </a:effectRef>
-          <a:fontRef idx="minor">
-            <a:schemeClr val="lt1"/>
-          </a:fontRef>
-        </p:style>
-        <p:txBody>
-          <a:bodyPr rtlCol="0" anchor="ctr" wrap="square"/>
-          <a:lstStyle/>
-          <a:p>
             <a:pPr algn="l"/>
             <a:r>
-              <a:rPr sz="1200" b="1">
-                <a:solidFill>
-                  <a:srgbClr val="FFFFFF"/>
-                </a:solidFill>
-              </a:rPr>
-              <a:t>✅ Validation</a:t>
-            </a:r>
-          </a:p>
-        </p:txBody>
-      </p:sp>
-      <p:sp>
-        <p:nvSpPr>
-          <p:cNvPr id="16" name="TextBox 15"/>
+              <a:rPr sz="1300" b="1">
+                <a:solidFill>
+                  <a:srgbClr val="003C6E"/>
+                </a:solidFill>
+              </a:rPr>
+              <a:t>⚡  Pipeline JSON</a:t>
+            </a:r>
+          </a:p>
+        </p:txBody>
+      </p:sp>
+      <p:sp>
+        <p:nvSpPr>
+          <p:cNvPr id="13" name="TextBox 12"/>
           <p:cNvSpPr txBox="1"/>
           <p:nvPr/>
         </p:nvSpPr>
         <p:spPr>
           <a:xfrm>
-            <a:off x="8165592" y="3392424"/>
-            <a:ext cx="3511296" cy="1133856"/>
+            <a:off x="438912" y="3566160"/>
+            <a:ext cx="2651760" cy="320040"/>
           </a:xfrm>
           <a:prstGeom prst="rect">
             <a:avLst/>
@@ -6102,144 +5602,72 @@
           </a:bodyPr>
           <a:lstStyle/>
           <a:p>
-            <a:pPr>
-              <a:spcAft>
-                <a:spcPts val="200"/>
-              </a:spcAft>
-            </a:pPr>
-            <a:r>
-              <a:rPr sz="1000">
-                <a:solidFill>
-                  <a:srgbClr val="2C3E50"/>
-                </a:solidFill>
-              </a:rPr>
-              <a:t>▸  6-level framework</a:t>
-            </a:r>
-          </a:p>
-          <a:p>
-            <a:pPr>
-              <a:spcAft>
-                <a:spcPts val="200"/>
-              </a:spcAft>
-            </a:pPr>
-            <a:r>
-              <a:rPr sz="1000">
-                <a:solidFill>
-                  <a:srgbClr val="2C3E50"/>
-                </a:solidFill>
-              </a:rPr>
-              <a:t>▸  Statistical tests (K-S)</a:t>
-            </a:r>
-          </a:p>
-          <a:p>
-            <a:pPr>
-              <a:spcAft>
-                <a:spcPts val="200"/>
-              </a:spcAft>
-            </a:pPr>
-            <a:r>
-              <a:rPr sz="1000">
-                <a:solidFill>
-                  <a:srgbClr val="2C3E50"/>
-                </a:solidFill>
-              </a:rPr>
-              <a:t>▸  SCD2 verification</a:t>
-            </a:r>
-          </a:p>
-          <a:p>
-            <a:pPr>
-              <a:spcAft>
-                <a:spcPts val="200"/>
-              </a:spcAft>
-            </a:pPr>
-            <a:r>
-              <a:rPr sz="1000">
-                <a:solidFill>
-                  <a:srgbClr val="2C3E50"/>
-                </a:solidFill>
-              </a:rPr>
-              <a:t>▸  RI checks + A/B testing</a:t>
-            </a:r>
-          </a:p>
-          <a:p>
-            <a:pPr>
-              <a:spcAft>
-                <a:spcPts val="200"/>
-              </a:spcAft>
-            </a:pPr>
-            <a:r>
-              <a:rPr sz="1000">
-                <a:solidFill>
-                  <a:srgbClr val="2C3E50"/>
-                </a:solidFill>
-              </a:rPr>
-              <a:t>▸  Business rule assertions</a:t>
-            </a:r>
-          </a:p>
-        </p:txBody>
-      </p:sp>
-      <p:sp>
-        <p:nvSpPr>
-          <p:cNvPr id="17" name="Rounded Rectangle 16"/>
-          <p:cNvSpPr/>
-          <p:nvPr/>
-        </p:nvSpPr>
-        <p:spPr>
-          <a:xfrm>
-            <a:off x="320040" y="4654296"/>
-            <a:ext cx="3657600" cy="384048"/>
-          </a:xfrm>
-          <a:prstGeom prst="roundRect">
-            <a:avLst/>
-          </a:prstGeom>
-          <a:solidFill>
-            <a:srgbClr val="1ABC9C"/>
-          </a:solidFill>
-          <a:ln>
-            <a:noFill/>
-          </a:ln>
-          <a:effectLst/>
-        </p:spPr>
-        <p:style>
-          <a:lnRef idx="1">
-            <a:schemeClr val="accent1"/>
-          </a:lnRef>
-          <a:fillRef idx="3">
-            <a:schemeClr val="accent1"/>
-          </a:fillRef>
-          <a:effectRef idx="2">
-            <a:schemeClr val="accent1"/>
-          </a:effectRef>
-          <a:fontRef idx="minor">
-            <a:schemeClr val="lt1"/>
-          </a:fontRef>
-        </p:style>
-        <p:txBody>
-          <a:bodyPr rtlCol="0" anchor="ctr" wrap="square"/>
-          <a:lstStyle/>
-          <a:p>
             <a:pPr algn="l"/>
             <a:r>
-              <a:rPr sz="1200" b="1">
-                <a:solidFill>
-                  <a:srgbClr val="FFFFFF"/>
-                </a:solidFill>
-              </a:rPr>
-              <a:t>🏗️ DevOps &amp; Infra</a:t>
-            </a:r>
-          </a:p>
-        </p:txBody>
-      </p:sp>
-      <p:sp>
-        <p:nvSpPr>
-          <p:cNvPr id="18" name="TextBox 17"/>
+              <a:rPr sz="1100" b="0">
+                <a:solidFill>
+                  <a:srgbClr val="2C3E50"/>
+                </a:solidFill>
+              </a:rPr>
+              <a:t>PL_*.json</a:t>
+            </a:r>
+          </a:p>
+        </p:txBody>
+      </p:sp>
+      <p:sp>
+        <p:nvSpPr>
+          <p:cNvPr id="14" name="Rounded Rectangle 13"/>
+          <p:cNvSpPr/>
+          <p:nvPr/>
+        </p:nvSpPr>
+        <p:spPr>
+          <a:xfrm>
+            <a:off x="274320" y="4160520"/>
+            <a:ext cx="109728" cy="640080"/>
+          </a:xfrm>
+          <a:prstGeom prst="roundRect">
+            <a:avLst/>
+          </a:prstGeom>
+          <a:solidFill>
+            <a:srgbClr val="FF694F"/>
+          </a:solidFill>
+          <a:ln>
+            <a:noFill/>
+          </a:ln>
+          <a:effectLst/>
+        </p:spPr>
+        <p:style>
+          <a:lnRef idx="1">
+            <a:schemeClr val="accent1"/>
+          </a:lnRef>
+          <a:fillRef idx="3">
+            <a:schemeClr val="accent1"/>
+          </a:fillRef>
+          <a:effectRef idx="2">
+            <a:schemeClr val="accent1"/>
+          </a:effectRef>
+          <a:fontRef idx="minor">
+            <a:schemeClr val="lt1"/>
+          </a:fontRef>
+        </p:style>
+        <p:txBody>
+          <a:bodyPr rtlCol="0" anchor="ctr"/>
+          <a:lstStyle/>
+          <a:p>
+            <a:pPr algn="ctr"/>
+          </a:p>
+        </p:txBody>
+      </p:sp>
+      <p:sp>
+        <p:nvSpPr>
+          <p:cNvPr id="15" name="TextBox 14"/>
           <p:cNvSpPr txBox="1"/>
           <p:nvPr/>
         </p:nvSpPr>
         <p:spPr>
           <a:xfrm>
-            <a:off x="393192" y="5056632"/>
-            <a:ext cx="3511296" cy="1133856"/>
+            <a:off x="438912" y="4160520"/>
+            <a:ext cx="2651760" cy="347472"/>
           </a:xfrm>
           <a:prstGeom prst="rect">
             <a:avLst/>
@@ -6252,144 +5680,28 @@
           </a:bodyPr>
           <a:lstStyle/>
           <a:p>
-            <a:pPr>
-              <a:spcAft>
-                <a:spcPts val="200"/>
-              </a:spcAft>
-            </a:pPr>
-            <a:r>
-              <a:rPr sz="1000">
-                <a:solidFill>
-                  <a:srgbClr val="2C3E50"/>
-                </a:solidFill>
-              </a:rPr>
-              <a:t>▸  Terraform + Bicep IaC</a:t>
-            </a:r>
-          </a:p>
-          <a:p>
-            <a:pPr>
-              <a:spcAft>
-                <a:spcPts val="200"/>
-              </a:spcAft>
-            </a:pPr>
-            <a:r>
-              <a:rPr sz="1000">
-                <a:solidFill>
-                  <a:srgbClr val="2C3E50"/>
-                </a:solidFill>
-              </a:rPr>
-              <a:t>▸  CI/CD (GitHub + ADO)</a:t>
-            </a:r>
-          </a:p>
-          <a:p>
-            <a:pPr>
-              <a:spcAft>
-                <a:spcPts val="200"/>
-              </a:spcAft>
-            </a:pPr>
-            <a:r>
-              <a:rPr sz="1000">
-                <a:solidFill>
-                  <a:srgbClr val="2C3E50"/>
-                </a:solidFill>
-              </a:rPr>
-              <a:t>▸  Docker / K8s / Helm</a:t>
-            </a:r>
-          </a:p>
-          <a:p>
-            <a:pPr>
-              <a:spcAft>
-                <a:spcPts val="200"/>
-              </a:spcAft>
-            </a:pPr>
-            <a:r>
-              <a:rPr sz="1000">
-                <a:solidFill>
-                  <a:srgbClr val="2C3E50"/>
-                </a:solidFill>
-              </a:rPr>
-              <a:t>▸  DAB bundles</a:t>
-            </a:r>
-          </a:p>
-          <a:p>
-            <a:pPr>
-              <a:spcAft>
-                <a:spcPts val="200"/>
-              </a:spcAft>
-            </a:pPr>
-            <a:r>
-              <a:rPr sz="1000">
-                <a:solidFill>
-                  <a:srgbClr val="2C3E50"/>
-                </a:solidFill>
-              </a:rPr>
-              <a:t>▸  Env promotion gates</a:t>
-            </a:r>
-          </a:p>
-        </p:txBody>
-      </p:sp>
-      <p:sp>
-        <p:nvSpPr>
-          <p:cNvPr id="19" name="Rounded Rectangle 18"/>
-          <p:cNvSpPr/>
-          <p:nvPr/>
-        </p:nvSpPr>
-        <p:spPr>
-          <a:xfrm>
-            <a:off x="4206240" y="4654296"/>
-            <a:ext cx="3657600" cy="384048"/>
-          </a:xfrm>
-          <a:prstGeom prst="roundRect">
-            <a:avLst/>
-          </a:prstGeom>
-          <a:solidFill>
-            <a:srgbClr val="003C6E"/>
-          </a:solidFill>
-          <a:ln>
-            <a:noFill/>
-          </a:ln>
-          <a:effectLst/>
-        </p:spPr>
-        <p:style>
-          <a:lnRef idx="1">
-            <a:schemeClr val="accent1"/>
-          </a:lnRef>
-          <a:fillRef idx="3">
-            <a:schemeClr val="accent1"/>
-          </a:fillRef>
-          <a:effectRef idx="2">
-            <a:schemeClr val="accent1"/>
-          </a:effectRef>
-          <a:fontRef idx="minor">
-            <a:schemeClr val="lt1"/>
-          </a:fontRef>
-        </p:style>
-        <p:txBody>
-          <a:bodyPr rtlCol="0" anchor="ctr" wrap="square"/>
-          <a:lstStyle/>
-          <a:p>
             <a:pPr algn="l"/>
             <a:r>
-              <a:rPr sz="1200" b="1">
-                <a:solidFill>
-                  <a:srgbClr val="FFFFFF"/>
-                </a:solidFill>
-              </a:rPr>
-              <a:t>🧠 ML &amp; Cost</a:t>
-            </a:r>
-          </a:p>
-        </p:txBody>
-      </p:sp>
-      <p:sp>
-        <p:nvSpPr>
-          <p:cNvPr id="20" name="TextBox 19"/>
+              <a:rPr sz="1300" b="1">
+                <a:solidFill>
+                  <a:srgbClr val="003C6E"/>
+                </a:solidFill>
+              </a:rPr>
+              <a:t>🏗️  DBT Models</a:t>
+            </a:r>
+          </a:p>
+        </p:txBody>
+      </p:sp>
+      <p:sp>
+        <p:nvSpPr>
+          <p:cNvPr id="16" name="TextBox 15"/>
           <p:cNvSpPr txBox="1"/>
           <p:nvPr/>
         </p:nvSpPr>
         <p:spPr>
           <a:xfrm>
-            <a:off x="4279392" y="5056632"/>
-            <a:ext cx="3511296" cy="1133856"/>
+            <a:off x="438912" y="4480560"/>
+            <a:ext cx="2651760" cy="320040"/>
           </a:xfrm>
           <a:prstGeom prst="rect">
             <a:avLst/>
@@ -6402,144 +5714,72 @@
           </a:bodyPr>
           <a:lstStyle/>
           <a:p>
-            <a:pPr>
-              <a:spcAft>
-                <a:spcPts val="200"/>
-              </a:spcAft>
-            </a:pPr>
-            <a:r>
-              <a:rPr sz="1000">
-                <a:solidFill>
-                  <a:srgbClr val="2C3E50"/>
-                </a:solidFill>
-              </a:rPr>
-              <a:t>▸  Feature Store notebooks</a:t>
-            </a:r>
-          </a:p>
-          <a:p>
-            <a:pPr>
-              <a:spcAft>
-                <a:spcPts val="200"/>
-              </a:spcAft>
-            </a:pPr>
-            <a:r>
-              <a:rPr sz="1000">
-                <a:solidFill>
-                  <a:srgbClr val="2C3E50"/>
-                </a:solidFill>
-              </a:rPr>
-              <a:t>▸  MLflow experiment tracking</a:t>
-            </a:r>
-          </a:p>
-          <a:p>
-            <a:pPr>
-              <a:spcAft>
-                <a:spcPts val="200"/>
-              </a:spcAft>
-            </a:pPr>
-            <a:r>
-              <a:rPr sz="1000">
-                <a:solidFill>
-                  <a:srgbClr val="2C3E50"/>
-                </a:solidFill>
-              </a:rPr>
-              <a:t>▸  Batch scoring pipelines</a:t>
-            </a:r>
-          </a:p>
-          <a:p>
-            <a:pPr>
-              <a:spcAft>
-                <a:spcPts val="200"/>
-              </a:spcAft>
-            </a:pPr>
-            <a:r>
-              <a:rPr sz="1000">
-                <a:solidFill>
-                  <a:srgbClr val="2C3E50"/>
-                </a:solidFill>
-              </a:rPr>
-              <a:t>▸  TCO / DBU cost estimator</a:t>
-            </a:r>
-          </a:p>
-          <a:p>
-            <a:pPr>
-              <a:spcAft>
-                <a:spcPts val="200"/>
-              </a:spcAft>
-            </a:pPr>
-            <a:r>
-              <a:rPr sz="1000">
-                <a:solidFill>
-                  <a:srgbClr val="2C3E50"/>
-                </a:solidFill>
-              </a:rPr>
-              <a:t>▸  Cost optimization advisor</a:t>
-            </a:r>
-          </a:p>
-        </p:txBody>
-      </p:sp>
-      <p:sp>
-        <p:nvSpPr>
-          <p:cNvPr id="21" name="Rounded Rectangle 20"/>
-          <p:cNvSpPr/>
-          <p:nvPr/>
-        </p:nvSpPr>
-        <p:spPr>
-          <a:xfrm>
-            <a:off x="8092440" y="4654296"/>
-            <a:ext cx="3657600" cy="384048"/>
-          </a:xfrm>
-          <a:prstGeom prst="roundRect">
-            <a:avLst/>
-          </a:prstGeom>
-          <a:solidFill>
-            <a:srgbClr val="FF4500"/>
-          </a:solidFill>
-          <a:ln>
-            <a:noFill/>
-          </a:ln>
-          <a:effectLst/>
-        </p:spPr>
-        <p:style>
-          <a:lnRef idx="1">
-            <a:schemeClr val="accent1"/>
-          </a:lnRef>
-          <a:fillRef idx="3">
-            <a:schemeClr val="accent1"/>
-          </a:fillRef>
-          <a:effectRef idx="2">
-            <a:schemeClr val="accent1"/>
-          </a:effectRef>
-          <a:fontRef idx="minor">
-            <a:schemeClr val="lt1"/>
-          </a:fontRef>
-        </p:style>
-        <p:txBody>
-          <a:bodyPr rtlCol="0" anchor="ctr" wrap="square"/>
-          <a:lstStyle/>
-          <a:p>
             <a:pPr algn="l"/>
             <a:r>
-              <a:rPr sz="1200" b="1">
-                <a:solidFill>
-                  <a:srgbClr val="FFFFFF"/>
-                </a:solidFill>
-              </a:rPr>
-              <a:t>🔌 Extensibility</a:t>
-            </a:r>
-          </a:p>
-        </p:txBody>
-      </p:sp>
-      <p:sp>
-        <p:nvSpPr>
-          <p:cNvPr id="22" name="TextBox 21"/>
+              <a:rPr sz="1100" b="0">
+                <a:solidFill>
+                  <a:srgbClr val="2C3E50"/>
+                </a:solidFill>
+              </a:rPr>
+              <a:t>staging / int / marts</a:t>
+            </a:r>
+          </a:p>
+        </p:txBody>
+      </p:sp>
+      <p:sp>
+        <p:nvSpPr>
+          <p:cNvPr id="17" name="Rounded Rectangle 16"/>
+          <p:cNvSpPr/>
+          <p:nvPr/>
+        </p:nvSpPr>
+        <p:spPr>
+          <a:xfrm>
+            <a:off x="274320" y="5074920"/>
+            <a:ext cx="109728" cy="640080"/>
+          </a:xfrm>
+          <a:prstGeom prst="roundRect">
+            <a:avLst/>
+          </a:prstGeom>
+          <a:solidFill>
+            <a:srgbClr val="1ABC9C"/>
+          </a:solidFill>
+          <a:ln>
+            <a:noFill/>
+          </a:ln>
+          <a:effectLst/>
+        </p:spPr>
+        <p:style>
+          <a:lnRef idx="1">
+            <a:schemeClr val="accent1"/>
+          </a:lnRef>
+          <a:fillRef idx="3">
+            <a:schemeClr val="accent1"/>
+          </a:fillRef>
+          <a:effectRef idx="2">
+            <a:schemeClr val="accent1"/>
+          </a:effectRef>
+          <a:fontRef idx="minor">
+            <a:schemeClr val="lt1"/>
+          </a:fontRef>
+        </p:style>
+        <p:txBody>
+          <a:bodyPr rtlCol="0" anchor="ctr"/>
+          <a:lstStyle/>
+          <a:p>
+            <a:pPr algn="ctr"/>
+          </a:p>
+        </p:txBody>
+      </p:sp>
+      <p:sp>
+        <p:nvSpPr>
+          <p:cNvPr id="18" name="TextBox 17"/>
           <p:cNvSpPr txBox="1"/>
           <p:nvPr/>
         </p:nvSpPr>
         <p:spPr>
           <a:xfrm>
-            <a:off x="8165592" y="5056632"/>
-            <a:ext cx="3511296" cy="1133856"/>
+            <a:off x="438912" y="5074920"/>
+            <a:ext cx="2651760" cy="347472"/>
           </a:xfrm>
           <a:prstGeom prst="rect">
             <a:avLst/>
@@ -6552,78 +5792,1762 @@
           </a:bodyPr>
           <a:lstStyle/>
           <a:p>
-            <a:pPr>
-              <a:spcAft>
-                <a:spcPts val="200"/>
-              </a:spcAft>
-            </a:pPr>
-            <a:r>
-              <a:rPr sz="1000">
-                <a:solidFill>
-                  <a:srgbClr val="2C3E50"/>
-                </a:solidFill>
-              </a:rPr>
-              <a:t>▸  Plugin system (decorators)</a:t>
-            </a:r>
-          </a:p>
-          <a:p>
-            <a:pPr>
-              <a:spcAft>
-                <a:spcPts val="200"/>
-              </a:spcAft>
-            </a:pPr>
-            <a:r>
-              <a:rPr sz="1000">
-                <a:solidFill>
-                  <a:srgbClr val="2C3E50"/>
-                </a:solidFill>
-              </a:rPr>
-              <a:t>▸  Python SDK + REST API</a:t>
-            </a:r>
-          </a:p>
-          <a:p>
-            <a:pPr>
-              <a:spcAft>
-                <a:spcPts val="200"/>
-              </a:spcAft>
-            </a:pPr>
-            <a:r>
-              <a:rPr sz="1000">
-                <a:solidFill>
-                  <a:srgbClr val="2C3E50"/>
-                </a:solidFill>
-              </a:rPr>
-              <a:t>▸  YAML/JSON rule engine</a:t>
-            </a:r>
-          </a:p>
-          <a:p>
-            <a:pPr>
-              <a:spcAft>
-                <a:spcPts val="200"/>
-              </a:spcAft>
-            </a:pPr>
-            <a:r>
-              <a:rPr sz="1000">
-                <a:solidFill>
-                  <a:srgbClr val="2C3E50"/>
-                </a:solidFill>
-              </a:rPr>
-              <a:t>▸  Purview / Unity Catalog</a:t>
-            </a:r>
-          </a:p>
-          <a:p>
-            <a:pPr>
-              <a:spcAft>
-                <a:spcPts val="200"/>
-              </a:spcAft>
-            </a:pPr>
-            <a:r>
-              <a:rPr sz="1000">
-                <a:solidFill>
-                  <a:srgbClr val="2C3E50"/>
-                </a:solidFill>
-              </a:rPr>
-              <a:t>▸  Visual lineage explorer</a:t>
+            <a:pPr algn="l"/>
+            <a:r>
+              <a:rPr sz="1300" b="1">
+                <a:solidFill>
+                  <a:srgbClr val="003C6E"/>
+                </a:solidFill>
+              </a:rPr>
+              <a:t>📐  Delta Lake DDL</a:t>
+            </a:r>
+          </a:p>
+        </p:txBody>
+      </p:sp>
+      <p:sp>
+        <p:nvSpPr>
+          <p:cNvPr id="19" name="TextBox 18"/>
+          <p:cNvSpPr txBox="1"/>
+          <p:nvPr/>
+        </p:nvSpPr>
+        <p:spPr>
+          <a:xfrm>
+            <a:off x="438912" y="5394960"/>
+            <a:ext cx="2651760" cy="320040"/>
+          </a:xfrm>
+          <a:prstGeom prst="rect">
+            <a:avLst/>
+          </a:prstGeom>
+          <a:noFill/>
+        </p:spPr>
+        <p:txBody>
+          <a:bodyPr wrap="square">
+            <a:spAutoFit/>
+          </a:bodyPr>
+          <a:lstStyle/>
+          <a:p>
+            <a:pPr algn="l"/>
+            <a:r>
+              <a:rPr sz="1100" b="0">
+                <a:solidFill>
+                  <a:srgbClr val="2C3E50"/>
+                </a:solidFill>
+              </a:rPr>
+              <a:t>CREATE TABLE + partitions</a:t>
+            </a:r>
+          </a:p>
+        </p:txBody>
+      </p:sp>
+      <p:sp>
+        <p:nvSpPr>
+          <p:cNvPr id="20" name="Rounded Rectangle 19"/>
+          <p:cNvSpPr/>
+          <p:nvPr/>
+        </p:nvSpPr>
+        <p:spPr>
+          <a:xfrm>
+            <a:off x="3200400" y="1417320"/>
+            <a:ext cx="109728" cy="640080"/>
+          </a:xfrm>
+          <a:prstGeom prst="roundRect">
+            <a:avLst/>
+          </a:prstGeom>
+          <a:solidFill>
+            <a:srgbClr val="FF4500"/>
+          </a:solidFill>
+          <a:ln>
+            <a:noFill/>
+          </a:ln>
+          <a:effectLst/>
+        </p:spPr>
+        <p:style>
+          <a:lnRef idx="1">
+            <a:schemeClr val="accent1"/>
+          </a:lnRef>
+          <a:fillRef idx="3">
+            <a:schemeClr val="accent1"/>
+          </a:fillRef>
+          <a:effectRef idx="2">
+            <a:schemeClr val="accent1"/>
+          </a:effectRef>
+          <a:fontRef idx="minor">
+            <a:schemeClr val="lt1"/>
+          </a:fontRef>
+        </p:style>
+        <p:txBody>
+          <a:bodyPr rtlCol="0" anchor="ctr"/>
+          <a:lstStyle/>
+          <a:p>
+            <a:pPr algn="ctr"/>
+          </a:p>
+        </p:txBody>
+      </p:sp>
+      <p:sp>
+        <p:nvSpPr>
+          <p:cNvPr id="21" name="TextBox 20"/>
+          <p:cNvSpPr txBox="1"/>
+          <p:nvPr/>
+        </p:nvSpPr>
+        <p:spPr>
+          <a:xfrm>
+            <a:off x="3364992" y="1417320"/>
+            <a:ext cx="2651760" cy="347472"/>
+          </a:xfrm>
+          <a:prstGeom prst="rect">
+            <a:avLst/>
+          </a:prstGeom>
+          <a:noFill/>
+        </p:spPr>
+        <p:txBody>
+          <a:bodyPr wrap="square">
+            <a:spAutoFit/>
+          </a:bodyPr>
+          <a:lstStyle/>
+          <a:p>
+            <a:pPr algn="l"/>
+            <a:r>
+              <a:rPr sz="1300" b="1">
+                <a:solidFill>
+                  <a:srgbClr val="003C6E"/>
+                </a:solidFill>
+              </a:rPr>
+              <a:t>⏰  AutoSys Pipelines</a:t>
+            </a:r>
+          </a:p>
+        </p:txBody>
+      </p:sp>
+      <p:sp>
+        <p:nvSpPr>
+          <p:cNvPr id="22" name="TextBox 21"/>
+          <p:cNvSpPr txBox="1"/>
+          <p:nvPr/>
+        </p:nvSpPr>
+        <p:spPr>
+          <a:xfrm>
+            <a:off x="3364992" y="1737360"/>
+            <a:ext cx="2651760" cy="320040"/>
+          </a:xfrm>
+          <a:prstGeom prst="rect">
+            <a:avLst/>
+          </a:prstGeom>
+          <a:noFill/>
+        </p:spPr>
+        <p:txBody>
+          <a:bodyPr wrap="square">
+            <a:spAutoFit/>
+          </a:bodyPr>
+          <a:lstStyle/>
+          <a:p>
+            <a:pPr algn="l"/>
+            <a:r>
+              <a:rPr sz="1100" b="0">
+                <a:solidFill>
+                  <a:srgbClr val="2C3E50"/>
+                </a:solidFill>
+              </a:rPr>
+              <a:t>JIL → Pipeline JSON</a:t>
+            </a:r>
+          </a:p>
+        </p:txBody>
+      </p:sp>
+      <p:sp>
+        <p:nvSpPr>
+          <p:cNvPr id="23" name="Rounded Rectangle 22"/>
+          <p:cNvSpPr/>
+          <p:nvPr/>
+        </p:nvSpPr>
+        <p:spPr>
+          <a:xfrm>
+            <a:off x="3200400" y="2331720"/>
+            <a:ext cx="109728" cy="640080"/>
+          </a:xfrm>
+          <a:prstGeom prst="roundRect">
+            <a:avLst/>
+          </a:prstGeom>
+          <a:solidFill>
+            <a:srgbClr val="E74C3C"/>
+          </a:solidFill>
+          <a:ln>
+            <a:noFill/>
+          </a:ln>
+          <a:effectLst/>
+        </p:spPr>
+        <p:style>
+          <a:lnRef idx="1">
+            <a:schemeClr val="accent1"/>
+          </a:lnRef>
+          <a:fillRef idx="3">
+            <a:schemeClr val="accent1"/>
+          </a:fillRef>
+          <a:effectRef idx="2">
+            <a:schemeClr val="accent1"/>
+          </a:effectRef>
+          <a:fontRef idx="minor">
+            <a:schemeClr val="lt1"/>
+          </a:fontRef>
+        </p:style>
+        <p:txBody>
+          <a:bodyPr rtlCol="0" anchor="ctr"/>
+          <a:lstStyle/>
+          <a:p>
+            <a:pPr algn="ctr"/>
+          </a:p>
+        </p:txBody>
+      </p:sp>
+      <p:sp>
+        <p:nvSpPr>
+          <p:cNvPr id="24" name="TextBox 23"/>
+          <p:cNvSpPr txBox="1"/>
+          <p:nvPr/>
+        </p:nvSpPr>
+        <p:spPr>
+          <a:xfrm>
+            <a:off x="3364992" y="2331720"/>
+            <a:ext cx="2651760" cy="347472"/>
+          </a:xfrm>
+          <a:prstGeom prst="rect">
+            <a:avLst/>
+          </a:prstGeom>
+          <a:noFill/>
+        </p:spPr>
+        <p:txBody>
+          <a:bodyPr wrap="square">
+            <a:spAutoFit/>
+          </a:bodyPr>
+          <a:lstStyle/>
+          <a:p>
+            <a:pPr algn="l"/>
+            <a:r>
+              <a:rPr sz="1300" b="1">
+                <a:solidFill>
+                  <a:srgbClr val="003C6E"/>
+                </a:solidFill>
+              </a:rPr>
+              <a:t>🌊  Streaming Notebooks</a:t>
+            </a:r>
+          </a:p>
+        </p:txBody>
+      </p:sp>
+      <p:sp>
+        <p:nvSpPr>
+          <p:cNvPr id="25" name="TextBox 24"/>
+          <p:cNvSpPr txBox="1"/>
+          <p:nvPr/>
+        </p:nvSpPr>
+        <p:spPr>
+          <a:xfrm>
+            <a:off x="3364992" y="2651760"/>
+            <a:ext cx="2651760" cy="320040"/>
+          </a:xfrm>
+          <a:prstGeom prst="rect">
+            <a:avLst/>
+          </a:prstGeom>
+          <a:noFill/>
+        </p:spPr>
+        <p:txBody>
+          <a:bodyPr wrap="square">
+            <a:spAutoFit/>
+          </a:bodyPr>
+          <a:lstStyle/>
+          <a:p>
+            <a:pPr algn="l"/>
+            <a:r>
+              <a:rPr sz="1100" b="0">
+                <a:solidFill>
+                  <a:srgbClr val="2C3E50"/>
+                </a:solidFill>
+              </a:rPr>
+              <a:t>CDC / MERGE INTO</a:t>
+            </a:r>
+          </a:p>
+        </p:txBody>
+      </p:sp>
+      <p:sp>
+        <p:nvSpPr>
+          <p:cNvPr id="26" name="Rounded Rectangle 25"/>
+          <p:cNvSpPr/>
+          <p:nvPr/>
+        </p:nvSpPr>
+        <p:spPr>
+          <a:xfrm>
+            <a:off x="3200400" y="3246120"/>
+            <a:ext cx="109728" cy="640080"/>
+          </a:xfrm>
+          <a:prstGeom prst="roundRect">
+            <a:avLst/>
+          </a:prstGeom>
+          <a:solidFill>
+            <a:srgbClr val="E74C3C"/>
+          </a:solidFill>
+          <a:ln>
+            <a:noFill/>
+          </a:ln>
+          <a:effectLst/>
+        </p:spPr>
+        <p:style>
+          <a:lnRef idx="1">
+            <a:schemeClr val="accent1"/>
+          </a:lnRef>
+          <a:fillRef idx="3">
+            <a:schemeClr val="accent1"/>
+          </a:fillRef>
+          <a:effectRef idx="2">
+            <a:schemeClr val="accent1"/>
+          </a:effectRef>
+          <a:fontRef idx="minor">
+            <a:schemeClr val="lt1"/>
+          </a:fontRef>
+        </p:style>
+        <p:txBody>
+          <a:bodyPr rtlCol="0" anchor="ctr"/>
+          <a:lstStyle/>
+          <a:p>
+            <a:pPr algn="ctr"/>
+          </a:p>
+        </p:txBody>
+      </p:sp>
+      <p:sp>
+        <p:nvSpPr>
+          <p:cNvPr id="27" name="TextBox 26"/>
+          <p:cNvSpPr txBox="1"/>
+          <p:nvPr/>
+        </p:nvSpPr>
+        <p:spPr>
+          <a:xfrm>
+            <a:off x="3364992" y="3246120"/>
+            <a:ext cx="2651760" cy="347472"/>
+          </a:xfrm>
+          <a:prstGeom prst="rect">
+            <a:avLst/>
+          </a:prstGeom>
+          <a:noFill/>
+        </p:spPr>
+        <p:txBody>
+          <a:bodyPr wrap="square">
+            <a:spAutoFit/>
+          </a:bodyPr>
+          <a:lstStyle/>
+          <a:p>
+            <a:pPr algn="l"/>
+            <a:r>
+              <a:rPr sz="1300" b="1">
+                <a:solidFill>
+                  <a:srgbClr val="003C6E"/>
+                </a:solidFill>
+              </a:rPr>
+              <a:t>⚙️  Azure Functions</a:t>
+            </a:r>
+          </a:p>
+        </p:txBody>
+      </p:sp>
+      <p:sp>
+        <p:nvSpPr>
+          <p:cNvPr id="28" name="TextBox 27"/>
+          <p:cNvSpPr txBox="1"/>
+          <p:nvPr/>
+        </p:nvSpPr>
+        <p:spPr>
+          <a:xfrm>
+            <a:off x="3364992" y="3566160"/>
+            <a:ext cx="2651760" cy="320040"/>
+          </a:xfrm>
+          <a:prstGeom prst="rect">
+            <a:avLst/>
+          </a:prstGeom>
+          <a:noFill/>
+        </p:spPr>
+        <p:txBody>
+          <a:bodyPr wrap="square">
+            <a:spAutoFit/>
+          </a:bodyPr>
+          <a:lstStyle/>
+          <a:p>
+            <a:pPr algn="l"/>
+            <a:r>
+              <a:rPr sz="1100" b="0">
+                <a:solidFill>
+                  <a:srgbClr val="2C3E50"/>
+                </a:solidFill>
+              </a:rPr>
+              <a:t>7 trigger types</a:t>
+            </a:r>
+          </a:p>
+        </p:txBody>
+      </p:sp>
+      <p:sp>
+        <p:nvSpPr>
+          <p:cNvPr id="29" name="Rounded Rectangle 28"/>
+          <p:cNvSpPr/>
+          <p:nvPr/>
+        </p:nvSpPr>
+        <p:spPr>
+          <a:xfrm>
+            <a:off x="3200400" y="4160520"/>
+            <a:ext cx="109728" cy="640080"/>
+          </a:xfrm>
+          <a:prstGeom prst="roundRect">
+            <a:avLst/>
+          </a:prstGeom>
+          <a:solidFill>
+            <a:srgbClr val="C0392B"/>
+          </a:solidFill>
+          <a:ln>
+            <a:noFill/>
+          </a:ln>
+          <a:effectLst/>
+        </p:spPr>
+        <p:style>
+          <a:lnRef idx="1">
+            <a:schemeClr val="accent1"/>
+          </a:lnRef>
+          <a:fillRef idx="3">
+            <a:schemeClr val="accent1"/>
+          </a:fillRef>
+          <a:effectRef idx="2">
+            <a:schemeClr val="accent1"/>
+          </a:effectRef>
+          <a:fontRef idx="minor">
+            <a:schemeClr val="lt1"/>
+          </a:fontRef>
+        </p:style>
+        <p:txBody>
+          <a:bodyPr rtlCol="0" anchor="ctr"/>
+          <a:lstStyle/>
+          <a:p>
+            <a:pPr algn="ctr"/>
+          </a:p>
+        </p:txBody>
+      </p:sp>
+      <p:sp>
+        <p:nvSpPr>
+          <p:cNvPr id="30" name="TextBox 29"/>
+          <p:cNvSpPr txBox="1"/>
+          <p:nvPr/>
+        </p:nvSpPr>
+        <p:spPr>
+          <a:xfrm>
+            <a:off x="3364992" y="4160520"/>
+            <a:ext cx="2651760" cy="347472"/>
+          </a:xfrm>
+          <a:prstGeom prst="rect">
+            <a:avLst/>
+          </a:prstGeom>
+          <a:noFill/>
+        </p:spPr>
+        <p:txBody>
+          <a:bodyPr wrap="square">
+            <a:spAutoFit/>
+          </a:bodyPr>
+          <a:lstStyle/>
+          <a:p>
+            <a:pPr algn="l"/>
+            <a:r>
+              <a:rPr sz="1300" b="1">
+                <a:solidFill>
+                  <a:srgbClr val="003C6E"/>
+                </a:solidFill>
+              </a:rPr>
+              <a:t>📡  Eventstream Defs</a:t>
+            </a:r>
+          </a:p>
+        </p:txBody>
+      </p:sp>
+      <p:sp>
+        <p:nvSpPr>
+          <p:cNvPr id="31" name="TextBox 30"/>
+          <p:cNvSpPr txBox="1"/>
+          <p:nvPr/>
+        </p:nvSpPr>
+        <p:spPr>
+          <a:xfrm>
+            <a:off x="3364992" y="4480560"/>
+            <a:ext cx="2651760" cy="320040"/>
+          </a:xfrm>
+          <a:prstGeom prst="rect">
+            <a:avLst/>
+          </a:prstGeom>
+          <a:noFill/>
+        </p:spPr>
+        <p:txBody>
+          <a:bodyPr wrap="square">
+            <a:spAutoFit/>
+          </a:bodyPr>
+          <a:lstStyle/>
+          <a:p>
+            <a:pPr algn="l"/>
+            <a:r>
+              <a:rPr sz="1100" b="0">
+                <a:solidFill>
+                  <a:srgbClr val="2C3E50"/>
+                </a:solidFill>
+              </a:rPr>
+              <a:t>Kafka / Event Hub</a:t>
+            </a:r>
+          </a:p>
+        </p:txBody>
+      </p:sp>
+      <p:sp>
+        <p:nvSpPr>
+          <p:cNvPr id="32" name="Rounded Rectangle 31"/>
+          <p:cNvSpPr/>
+          <p:nvPr/>
+        </p:nvSpPr>
+        <p:spPr>
+          <a:xfrm>
+            <a:off x="3200400" y="5074920"/>
+            <a:ext cx="109728" cy="640080"/>
+          </a:xfrm>
+          <a:prstGeom prst="roundRect">
+            <a:avLst/>
+          </a:prstGeom>
+          <a:solidFill>
+            <a:srgbClr val="632CA6"/>
+          </a:solidFill>
+          <a:ln>
+            <a:noFill/>
+          </a:ln>
+          <a:effectLst/>
+        </p:spPr>
+        <p:style>
+          <a:lnRef idx="1">
+            <a:schemeClr val="accent1"/>
+          </a:lnRef>
+          <a:fillRef idx="3">
+            <a:schemeClr val="accent1"/>
+          </a:fillRef>
+          <a:effectRef idx="2">
+            <a:schemeClr val="accent1"/>
+          </a:effectRef>
+          <a:fontRef idx="minor">
+            <a:schemeClr val="lt1"/>
+          </a:fontRef>
+        </p:style>
+        <p:txBody>
+          <a:bodyPr rtlCol="0" anchor="ctr"/>
+          <a:lstStyle/>
+          <a:p>
+            <a:pPr algn="ctr"/>
+          </a:p>
+        </p:txBody>
+      </p:sp>
+      <p:sp>
+        <p:nvSpPr>
+          <p:cNvPr id="33" name="TextBox 32"/>
+          <p:cNvSpPr txBox="1"/>
+          <p:nvPr/>
+        </p:nvSpPr>
+        <p:spPr>
+          <a:xfrm>
+            <a:off x="3364992" y="5074920"/>
+            <a:ext cx="2651760" cy="347472"/>
+          </a:xfrm>
+          <a:prstGeom prst="rect">
+            <a:avLst/>
+          </a:prstGeom>
+          <a:noFill/>
+        </p:spPr>
+        <p:txBody>
+          <a:bodyPr wrap="square">
+            <a:spAutoFit/>
+          </a:bodyPr>
+          <a:lstStyle/>
+          <a:p>
+            <a:pPr algn="l"/>
+            <a:r>
+              <a:rPr sz="1300" b="1">
+                <a:solidFill>
+                  <a:srgbClr val="003C6E"/>
+                </a:solidFill>
+              </a:rPr>
+              <a:t>🔗  Deployment Blueprints</a:t>
+            </a:r>
+          </a:p>
+        </p:txBody>
+      </p:sp>
+      <p:sp>
+        <p:nvSpPr>
+          <p:cNvPr id="34" name="TextBox 33"/>
+          <p:cNvSpPr txBox="1"/>
+          <p:nvPr/>
+        </p:nvSpPr>
+        <p:spPr>
+          <a:xfrm>
+            <a:off x="3364992" y="5394960"/>
+            <a:ext cx="2651760" cy="320040"/>
+          </a:xfrm>
+          <a:prstGeom prst="rect">
+            <a:avLst/>
+          </a:prstGeom>
+          <a:noFill/>
+        </p:spPr>
+        <p:txBody>
+          <a:bodyPr wrap="square">
+            <a:spAutoFit/>
+          </a:bodyPr>
+          <a:lstStyle/>
+          <a:p>
+            <a:pPr algn="l"/>
+            <a:r>
+              <a:rPr sz="1100" b="0">
+                <a:solidFill>
+                  <a:srgbClr val="2C3E50"/>
+                </a:solidFill>
+              </a:rPr>
+              <a:t>Bicep / Terraform</a:t>
+            </a:r>
+          </a:p>
+        </p:txBody>
+      </p:sp>
+      <p:sp>
+        <p:nvSpPr>
+          <p:cNvPr id="35" name="Rounded Rectangle 34"/>
+          <p:cNvSpPr/>
+          <p:nvPr/>
+        </p:nvSpPr>
+        <p:spPr>
+          <a:xfrm>
+            <a:off x="6126480" y="1417320"/>
+            <a:ext cx="109728" cy="640080"/>
+          </a:xfrm>
+          <a:prstGeom prst="roundRect">
+            <a:avLst/>
+          </a:prstGeom>
+          <a:solidFill>
+            <a:srgbClr val="27AE60"/>
+          </a:solidFill>
+          <a:ln>
+            <a:noFill/>
+          </a:ln>
+          <a:effectLst/>
+        </p:spPr>
+        <p:style>
+          <a:lnRef idx="1">
+            <a:schemeClr val="accent1"/>
+          </a:lnRef>
+          <a:fillRef idx="3">
+            <a:schemeClr val="accent1"/>
+          </a:fillRef>
+          <a:effectRef idx="2">
+            <a:schemeClr val="accent1"/>
+          </a:effectRef>
+          <a:fontRef idx="minor">
+            <a:schemeClr val="lt1"/>
+          </a:fontRef>
+        </p:style>
+        <p:txBody>
+          <a:bodyPr rtlCol="0" anchor="ctr"/>
+          <a:lstStyle/>
+          <a:p>
+            <a:pPr algn="ctr"/>
+          </a:p>
+        </p:txBody>
+      </p:sp>
+      <p:sp>
+        <p:nvSpPr>
+          <p:cNvPr id="36" name="TextBox 35"/>
+          <p:cNvSpPr txBox="1"/>
+          <p:nvPr/>
+        </p:nvSpPr>
+        <p:spPr>
+          <a:xfrm>
+            <a:off x="6291072" y="1417320"/>
+            <a:ext cx="2651760" cy="347472"/>
+          </a:xfrm>
+          <a:prstGeom prst="rect">
+            <a:avLst/>
+          </a:prstGeom>
+          <a:noFill/>
+        </p:spPr>
+        <p:txBody>
+          <a:bodyPr wrap="square">
+            <a:spAutoFit/>
+          </a:bodyPr>
+          <a:lstStyle/>
+          <a:p>
+            <a:pPr algn="l"/>
+            <a:r>
+              <a:rPr sz="1300" b="1">
+                <a:solidFill>
+                  <a:srgbClr val="003C6E"/>
+                </a:solidFill>
+              </a:rPr>
+              <a:t>✅  Validation Scripts</a:t>
+            </a:r>
+          </a:p>
+        </p:txBody>
+      </p:sp>
+      <p:sp>
+        <p:nvSpPr>
+          <p:cNvPr id="37" name="TextBox 36"/>
+          <p:cNvSpPr txBox="1"/>
+          <p:nvPr/>
+        </p:nvSpPr>
+        <p:spPr>
+          <a:xfrm>
+            <a:off x="6291072" y="1737360"/>
+            <a:ext cx="2651760" cy="320040"/>
+          </a:xfrm>
+          <a:prstGeom prst="rect">
+            <a:avLst/>
+          </a:prstGeom>
+          <a:noFill/>
+        </p:spPr>
+        <p:txBody>
+          <a:bodyPr wrap="square">
+            <a:spAutoFit/>
+          </a:bodyPr>
+          <a:lstStyle/>
+          <a:p>
+            <a:pPr algn="l"/>
+            <a:r>
+              <a:rPr sz="1100" b="0">
+                <a:solidFill>
+                  <a:srgbClr val="2C3E50"/>
+                </a:solidFill>
+              </a:rPr>
+              <a:t>VAL_*.py (6 levels)</a:t>
+            </a:r>
+          </a:p>
+        </p:txBody>
+      </p:sp>
+      <p:sp>
+        <p:nvSpPr>
+          <p:cNvPr id="38" name="Rounded Rectangle 37"/>
+          <p:cNvSpPr/>
+          <p:nvPr/>
+        </p:nvSpPr>
+        <p:spPr>
+          <a:xfrm>
+            <a:off x="6126480" y="2331720"/>
+            <a:ext cx="109728" cy="640080"/>
+          </a:xfrm>
+          <a:prstGeom prst="roundRect">
+            <a:avLst/>
+          </a:prstGeom>
+          <a:solidFill>
+            <a:srgbClr val="0078D4"/>
+          </a:solidFill>
+          <a:ln>
+            <a:noFill/>
+          </a:ln>
+          <a:effectLst/>
+        </p:spPr>
+        <p:style>
+          <a:lnRef idx="1">
+            <a:schemeClr val="accent1"/>
+          </a:lnRef>
+          <a:fillRef idx="3">
+            <a:schemeClr val="accent1"/>
+          </a:fillRef>
+          <a:effectRef idx="2">
+            <a:schemeClr val="accent1"/>
+          </a:effectRef>
+          <a:fontRef idx="minor">
+            <a:schemeClr val="lt1"/>
+          </a:fontRef>
+        </p:style>
+        <p:txBody>
+          <a:bodyPr rtlCol="0" anchor="ctr"/>
+          <a:lstStyle/>
+          <a:p>
+            <a:pPr algn="ctr"/>
+          </a:p>
+        </p:txBody>
+      </p:sp>
+      <p:sp>
+        <p:nvSpPr>
+          <p:cNvPr id="39" name="TextBox 38"/>
+          <p:cNvSpPr txBox="1"/>
+          <p:nvPr/>
+        </p:nvSpPr>
+        <p:spPr>
+          <a:xfrm>
+            <a:off x="6291072" y="2331720"/>
+            <a:ext cx="2651760" cy="347472"/>
+          </a:xfrm>
+          <a:prstGeom prst="rect">
+            <a:avLst/>
+          </a:prstGeom>
+          <a:noFill/>
+        </p:spPr>
+        <p:txBody>
+          <a:bodyPr wrap="square">
+            <a:spAutoFit/>
+          </a:bodyPr>
+          <a:lstStyle/>
+          <a:p>
+            <a:pPr algn="l"/>
+            <a:r>
+              <a:rPr sz="1300" b="1">
+                <a:solidFill>
+                  <a:srgbClr val="003C6E"/>
+                </a:solidFill>
+              </a:rPr>
+              <a:t>📊  Inventory &amp; Reports</a:t>
+            </a:r>
+          </a:p>
+        </p:txBody>
+      </p:sp>
+      <p:sp>
+        <p:nvSpPr>
+          <p:cNvPr id="40" name="TextBox 39"/>
+          <p:cNvSpPr txBox="1"/>
+          <p:nvPr/>
+        </p:nvSpPr>
+        <p:spPr>
+          <a:xfrm>
+            <a:off x="6291072" y="2651760"/>
+            <a:ext cx="2651760" cy="320040"/>
+          </a:xfrm>
+          <a:prstGeom prst="rect">
+            <a:avLst/>
+          </a:prstGeom>
+          <a:noFill/>
+        </p:spPr>
+        <p:txBody>
+          <a:bodyPr wrap="square">
+            <a:spAutoFit/>
+          </a:bodyPr>
+          <a:lstStyle/>
+          <a:p>
+            <a:pPr algn="l"/>
+            <a:r>
+              <a:rPr sz="1100" b="0">
+                <a:solidFill>
+                  <a:srgbClr val="2C3E50"/>
+                </a:solidFill>
+              </a:rPr>
+              <a:t>JSON + HTML + SVG</a:t>
+            </a:r>
+          </a:p>
+        </p:txBody>
+      </p:sp>
+      <p:sp>
+        <p:nvSpPr>
+          <p:cNvPr id="41" name="Rounded Rectangle 40"/>
+          <p:cNvSpPr/>
+          <p:nvPr/>
+        </p:nvSpPr>
+        <p:spPr>
+          <a:xfrm>
+            <a:off x="6126480" y="3246120"/>
+            <a:ext cx="109728" cy="640080"/>
+          </a:xfrm>
+          <a:prstGeom prst="roundRect">
+            <a:avLst/>
+          </a:prstGeom>
+          <a:solidFill>
+            <a:srgbClr val="F39C12"/>
+          </a:solidFill>
+          <a:ln>
+            <a:noFill/>
+          </a:ln>
+          <a:effectLst/>
+        </p:spPr>
+        <p:style>
+          <a:lnRef idx="1">
+            <a:schemeClr val="accent1"/>
+          </a:lnRef>
+          <a:fillRef idx="3">
+            <a:schemeClr val="accent1"/>
+          </a:fillRef>
+          <a:effectRef idx="2">
+            <a:schemeClr val="accent1"/>
+          </a:effectRef>
+          <a:fontRef idx="minor">
+            <a:schemeClr val="lt1"/>
+          </a:fontRef>
+        </p:style>
+        <p:txBody>
+          <a:bodyPr rtlCol="0" anchor="ctr"/>
+          <a:lstStyle/>
+          <a:p>
+            <a:pPr algn="ctr"/>
+          </a:p>
+        </p:txBody>
+      </p:sp>
+      <p:sp>
+        <p:nvSpPr>
+          <p:cNvPr id="42" name="TextBox 41"/>
+          <p:cNvSpPr txBox="1"/>
+          <p:nvPr/>
+        </p:nvSpPr>
+        <p:spPr>
+          <a:xfrm>
+            <a:off x="6291072" y="3246120"/>
+            <a:ext cx="2651760" cy="347472"/>
+          </a:xfrm>
+          <a:prstGeom prst="rect">
+            <a:avLst/>
+          </a:prstGeom>
+          <a:noFill/>
+        </p:spPr>
+        <p:txBody>
+          <a:bodyPr wrap="square">
+            <a:spAutoFit/>
+          </a:bodyPr>
+          <a:lstStyle/>
+          <a:p>
+            <a:pPr algn="l"/>
+            <a:r>
+              <a:rPr sz="1300" b="1">
+                <a:solidFill>
+                  <a:srgbClr val="003C6E"/>
+                </a:solidFill>
+              </a:rPr>
+              <a:t>🔒  Security Policies</a:t>
+            </a:r>
+          </a:p>
+        </p:txBody>
+      </p:sp>
+      <p:sp>
+        <p:nvSpPr>
+          <p:cNvPr id="43" name="TextBox 42"/>
+          <p:cNvSpPr txBox="1"/>
+          <p:nvPr/>
+        </p:nvSpPr>
+        <p:spPr>
+          <a:xfrm>
+            <a:off x="6291072" y="3566160"/>
+            <a:ext cx="2651760" cy="320040"/>
+          </a:xfrm>
+          <a:prstGeom prst="rect">
+            <a:avLst/>
+          </a:prstGeom>
+          <a:noFill/>
+        </p:spPr>
+        <p:txBody>
+          <a:bodyPr wrap="square">
+            <a:spAutoFit/>
+          </a:bodyPr>
+          <a:lstStyle/>
+          <a:p>
+            <a:pPr algn="l"/>
+            <a:r>
+              <a:rPr sz="1100" b="0">
+                <a:solidFill>
+                  <a:srgbClr val="2C3E50"/>
+                </a:solidFill>
+              </a:rPr>
+              <a:t>RLS / column masking</a:t>
+            </a:r>
+          </a:p>
+        </p:txBody>
+      </p:sp>
+      <p:sp>
+        <p:nvSpPr>
+          <p:cNvPr id="44" name="Rounded Rectangle 43"/>
+          <p:cNvSpPr/>
+          <p:nvPr/>
+        </p:nvSpPr>
+        <p:spPr>
+          <a:xfrm>
+            <a:off x="6126480" y="4160520"/>
+            <a:ext cx="109728" cy="640080"/>
+          </a:xfrm>
+          <a:prstGeom prst="roundRect">
+            <a:avLst/>
+          </a:prstGeom>
+          <a:solidFill>
+            <a:srgbClr val="F39C12"/>
+          </a:solidFill>
+          <a:ln>
+            <a:noFill/>
+          </a:ln>
+          <a:effectLst/>
+        </p:spPr>
+        <p:style>
+          <a:lnRef idx="1">
+            <a:schemeClr val="accent1"/>
+          </a:lnRef>
+          <a:fillRef idx="3">
+            <a:schemeClr val="accent1"/>
+          </a:fillRef>
+          <a:effectRef idx="2">
+            <a:schemeClr val="accent1"/>
+          </a:effectRef>
+          <a:fontRef idx="minor">
+            <a:schemeClr val="lt1"/>
+          </a:fontRef>
+        </p:style>
+        <p:txBody>
+          <a:bodyPr rtlCol="0" anchor="ctr"/>
+          <a:lstStyle/>
+          <a:p>
+            <a:pPr algn="ctr"/>
+          </a:p>
+        </p:txBody>
+      </p:sp>
+      <p:sp>
+        <p:nvSpPr>
+          <p:cNvPr id="45" name="TextBox 44"/>
+          <p:cNvSpPr txBox="1"/>
+          <p:nvPr/>
+        </p:nvSpPr>
+        <p:spPr>
+          <a:xfrm>
+            <a:off x="6291072" y="4160520"/>
+            <a:ext cx="2651760" cy="347472"/>
+          </a:xfrm>
+          <a:prstGeom prst="rect">
+            <a:avLst/>
+          </a:prstGeom>
+          <a:noFill/>
+        </p:spPr>
+        <p:txBody>
+          <a:bodyPr wrap="square">
+            <a:spAutoFit/>
+          </a:bodyPr>
+          <a:lstStyle/>
+          <a:p>
+            <a:pPr algn="l"/>
+            <a:r>
+              <a:rPr sz="1300" b="1">
+                <a:solidFill>
+                  <a:srgbClr val="003C6E"/>
+                </a:solidFill>
+              </a:rPr>
+              <a:t>📋  Compliance Docs</a:t>
+            </a:r>
+          </a:p>
+        </p:txBody>
+      </p:sp>
+      <p:sp>
+        <p:nvSpPr>
+          <p:cNvPr id="46" name="TextBox 45"/>
+          <p:cNvSpPr txBox="1"/>
+          <p:nvPr/>
+        </p:nvSpPr>
+        <p:spPr>
+          <a:xfrm>
+            <a:off x="6291072" y="4480560"/>
+            <a:ext cx="2651760" cy="320040"/>
+          </a:xfrm>
+          <a:prstGeom prst="rect">
+            <a:avLst/>
+          </a:prstGeom>
+          <a:noFill/>
+        </p:spPr>
+        <p:txBody>
+          <a:bodyPr wrap="square">
+            <a:spAutoFit/>
+          </a:bodyPr>
+          <a:lstStyle/>
+          <a:p>
+            <a:pPr algn="l"/>
+            <a:r>
+              <a:rPr sz="1100" b="0">
+                <a:solidFill>
+                  <a:srgbClr val="2C3E50"/>
+                </a:solidFill>
+              </a:rPr>
+              <a:t>GDPR / CCPA / PII</a:t>
+            </a:r>
+          </a:p>
+        </p:txBody>
+      </p:sp>
+      <p:sp>
+        <p:nvSpPr>
+          <p:cNvPr id="47" name="Rounded Rectangle 46"/>
+          <p:cNvSpPr/>
+          <p:nvPr/>
+        </p:nvSpPr>
+        <p:spPr>
+          <a:xfrm>
+            <a:off x="6126480" y="5074920"/>
+            <a:ext cx="109728" cy="640080"/>
+          </a:xfrm>
+          <a:prstGeom prst="roundRect">
+            <a:avLst/>
+          </a:prstGeom>
+          <a:solidFill>
+            <a:srgbClr val="003C6E"/>
+          </a:solidFill>
+          <a:ln>
+            <a:noFill/>
+          </a:ln>
+          <a:effectLst/>
+        </p:spPr>
+        <p:style>
+          <a:lnRef idx="1">
+            <a:schemeClr val="accent1"/>
+          </a:lnRef>
+          <a:fillRef idx="3">
+            <a:schemeClr val="accent1"/>
+          </a:fillRef>
+          <a:effectRef idx="2">
+            <a:schemeClr val="accent1"/>
+          </a:effectRef>
+          <a:fontRef idx="minor">
+            <a:schemeClr val="lt1"/>
+          </a:fontRef>
+        </p:style>
+        <p:txBody>
+          <a:bodyPr rtlCol="0" anchor="ctr"/>
+          <a:lstStyle/>
+          <a:p>
+            <a:pPr algn="ctr"/>
+          </a:p>
+        </p:txBody>
+      </p:sp>
+      <p:sp>
+        <p:nvSpPr>
+          <p:cNvPr id="48" name="TextBox 47"/>
+          <p:cNvSpPr txBox="1"/>
+          <p:nvPr/>
+        </p:nvSpPr>
+        <p:spPr>
+          <a:xfrm>
+            <a:off x="6291072" y="5074920"/>
+            <a:ext cx="2651760" cy="347472"/>
+          </a:xfrm>
+          <a:prstGeom prst="rect">
+            <a:avLst/>
+          </a:prstGeom>
+          <a:noFill/>
+        </p:spPr>
+        <p:txBody>
+          <a:bodyPr wrap="square">
+            <a:spAutoFit/>
+          </a:bodyPr>
+          <a:lstStyle/>
+          <a:p>
+            <a:pPr algn="l"/>
+            <a:r>
+              <a:rPr sz="1300" b="1">
+                <a:solidFill>
+                  <a:srgbClr val="003C6E"/>
+                </a:solidFill>
+              </a:rPr>
+              <a:t>🏷️  Catalog Metadata</a:t>
+            </a:r>
+          </a:p>
+        </p:txBody>
+      </p:sp>
+      <p:sp>
+        <p:nvSpPr>
+          <p:cNvPr id="49" name="TextBox 48"/>
+          <p:cNvSpPr txBox="1"/>
+          <p:nvPr/>
+        </p:nvSpPr>
+        <p:spPr>
+          <a:xfrm>
+            <a:off x="6291072" y="5394960"/>
+            <a:ext cx="2651760" cy="320040"/>
+          </a:xfrm>
+          <a:prstGeom prst="rect">
+            <a:avLst/>
+          </a:prstGeom>
+          <a:noFill/>
+        </p:spPr>
+        <p:txBody>
+          <a:bodyPr wrap="square">
+            <a:spAutoFit/>
+          </a:bodyPr>
+          <a:lstStyle/>
+          <a:p>
+            <a:pPr algn="l"/>
+            <a:r>
+              <a:rPr sz="1100" b="0">
+                <a:solidFill>
+                  <a:srgbClr val="2C3E50"/>
+                </a:solidFill>
+              </a:rPr>
+              <a:t>Purview / Unity Catalog</a:t>
+            </a:r>
+          </a:p>
+        </p:txBody>
+      </p:sp>
+      <p:sp>
+        <p:nvSpPr>
+          <p:cNvPr id="50" name="Rounded Rectangle 49"/>
+          <p:cNvSpPr/>
+          <p:nvPr/>
+        </p:nvSpPr>
+        <p:spPr>
+          <a:xfrm>
+            <a:off x="9052560" y="1417320"/>
+            <a:ext cx="109728" cy="640080"/>
+          </a:xfrm>
+          <a:prstGeom prst="roundRect">
+            <a:avLst/>
+          </a:prstGeom>
+          <a:solidFill>
+            <a:srgbClr val="1ABC9C"/>
+          </a:solidFill>
+          <a:ln>
+            <a:noFill/>
+          </a:ln>
+          <a:effectLst/>
+        </p:spPr>
+        <p:style>
+          <a:lnRef idx="1">
+            <a:schemeClr val="accent1"/>
+          </a:lnRef>
+          <a:fillRef idx="3">
+            <a:schemeClr val="accent1"/>
+          </a:fillRef>
+          <a:effectRef idx="2">
+            <a:schemeClr val="accent1"/>
+          </a:effectRef>
+          <a:fontRef idx="minor">
+            <a:schemeClr val="lt1"/>
+          </a:fontRef>
+        </p:style>
+        <p:txBody>
+          <a:bodyPr rtlCol="0" anchor="ctr"/>
+          <a:lstStyle/>
+          <a:p>
+            <a:pPr algn="ctr"/>
+          </a:p>
+        </p:txBody>
+      </p:sp>
+      <p:sp>
+        <p:nvSpPr>
+          <p:cNvPr id="51" name="TextBox 50"/>
+          <p:cNvSpPr txBox="1"/>
+          <p:nvPr/>
+        </p:nvSpPr>
+        <p:spPr>
+          <a:xfrm>
+            <a:off x="9217152" y="1417320"/>
+            <a:ext cx="2651760" cy="347472"/>
+          </a:xfrm>
+          <a:prstGeom prst="rect">
+            <a:avLst/>
+          </a:prstGeom>
+          <a:noFill/>
+        </p:spPr>
+        <p:txBody>
+          <a:bodyPr wrap="square">
+            <a:spAutoFit/>
+          </a:bodyPr>
+          <a:lstStyle/>
+          <a:p>
+            <a:pPr algn="l"/>
+            <a:r>
+              <a:rPr sz="1300" b="1">
+                <a:solidFill>
+                  <a:srgbClr val="003C6E"/>
+                </a:solidFill>
+              </a:rPr>
+              <a:t>🏗️  IaC Templates</a:t>
+            </a:r>
+          </a:p>
+        </p:txBody>
+      </p:sp>
+      <p:sp>
+        <p:nvSpPr>
+          <p:cNvPr id="52" name="TextBox 51"/>
+          <p:cNvSpPr txBox="1"/>
+          <p:nvPr/>
+        </p:nvSpPr>
+        <p:spPr>
+          <a:xfrm>
+            <a:off x="9217152" y="1737360"/>
+            <a:ext cx="2651760" cy="320040"/>
+          </a:xfrm>
+          <a:prstGeom prst="rect">
+            <a:avLst/>
+          </a:prstGeom>
+          <a:noFill/>
+        </p:spPr>
+        <p:txBody>
+          <a:bodyPr wrap="square">
+            <a:spAutoFit/>
+          </a:bodyPr>
+          <a:lstStyle/>
+          <a:p>
+            <a:pPr algn="l"/>
+            <a:r>
+              <a:rPr sz="1100" b="0">
+                <a:solidFill>
+                  <a:srgbClr val="2C3E50"/>
+                </a:solidFill>
+              </a:rPr>
+              <a:t>Terraform HCL + Bicep</a:t>
+            </a:r>
+          </a:p>
+        </p:txBody>
+      </p:sp>
+      <p:sp>
+        <p:nvSpPr>
+          <p:cNvPr id="53" name="Rounded Rectangle 52"/>
+          <p:cNvSpPr/>
+          <p:nvPr/>
+        </p:nvSpPr>
+        <p:spPr>
+          <a:xfrm>
+            <a:off x="9052560" y="2331720"/>
+            <a:ext cx="109728" cy="640080"/>
+          </a:xfrm>
+          <a:prstGeom prst="roundRect">
+            <a:avLst/>
+          </a:prstGeom>
+          <a:solidFill>
+            <a:srgbClr val="27AE60"/>
+          </a:solidFill>
+          <a:ln>
+            <a:noFill/>
+          </a:ln>
+          <a:effectLst/>
+        </p:spPr>
+        <p:style>
+          <a:lnRef idx="1">
+            <a:schemeClr val="accent1"/>
+          </a:lnRef>
+          <a:fillRef idx="3">
+            <a:schemeClr val="accent1"/>
+          </a:fillRef>
+          <a:effectRef idx="2">
+            <a:schemeClr val="accent1"/>
+          </a:effectRef>
+          <a:fontRef idx="minor">
+            <a:schemeClr val="lt1"/>
+          </a:fontRef>
+        </p:style>
+        <p:txBody>
+          <a:bodyPr rtlCol="0" anchor="ctr"/>
+          <a:lstStyle/>
+          <a:p>
+            <a:pPr algn="ctr"/>
+          </a:p>
+        </p:txBody>
+      </p:sp>
+      <p:sp>
+        <p:nvSpPr>
+          <p:cNvPr id="54" name="TextBox 53"/>
+          <p:cNvSpPr txBox="1"/>
+          <p:nvPr/>
+        </p:nvSpPr>
+        <p:spPr>
+          <a:xfrm>
+            <a:off x="9217152" y="2331720"/>
+            <a:ext cx="2651760" cy="347472"/>
+          </a:xfrm>
+          <a:prstGeom prst="rect">
+            <a:avLst/>
+          </a:prstGeom>
+          <a:noFill/>
+        </p:spPr>
+        <p:txBody>
+          <a:bodyPr wrap="square">
+            <a:spAutoFit/>
+          </a:bodyPr>
+          <a:lstStyle/>
+          <a:p>
+            <a:pPr algn="l"/>
+            <a:r>
+              <a:rPr sz="1300" b="1">
+                <a:solidFill>
+                  <a:srgbClr val="003C6E"/>
+                </a:solidFill>
+              </a:rPr>
+              <a:t>🔄  CI/CD Pipelines</a:t>
+            </a:r>
+          </a:p>
+        </p:txBody>
+      </p:sp>
+      <p:sp>
+        <p:nvSpPr>
+          <p:cNvPr id="55" name="TextBox 54"/>
+          <p:cNvSpPr txBox="1"/>
+          <p:nvPr/>
+        </p:nvSpPr>
+        <p:spPr>
+          <a:xfrm>
+            <a:off x="9217152" y="2651760"/>
+            <a:ext cx="2651760" cy="320040"/>
+          </a:xfrm>
+          <a:prstGeom prst="rect">
+            <a:avLst/>
+          </a:prstGeom>
+          <a:noFill/>
+        </p:spPr>
+        <p:txBody>
+          <a:bodyPr wrap="square">
+            <a:spAutoFit/>
+          </a:bodyPr>
+          <a:lstStyle/>
+          <a:p>
+            <a:pPr algn="l"/>
+            <a:r>
+              <a:rPr sz="1100" b="0">
+                <a:solidFill>
+                  <a:srgbClr val="2C3E50"/>
+                </a:solidFill>
+              </a:rPr>
+              <a:t>GitHub Actions / ADO</a:t>
+            </a:r>
+          </a:p>
+        </p:txBody>
+      </p:sp>
+      <p:sp>
+        <p:nvSpPr>
+          <p:cNvPr id="56" name="Rounded Rectangle 55"/>
+          <p:cNvSpPr/>
+          <p:nvPr/>
+        </p:nvSpPr>
+        <p:spPr>
+          <a:xfrm>
+            <a:off x="9052560" y="3246120"/>
+            <a:ext cx="109728" cy="640080"/>
+          </a:xfrm>
+          <a:prstGeom prst="roundRect">
+            <a:avLst/>
+          </a:prstGeom>
+          <a:solidFill>
+            <a:srgbClr val="0078D4"/>
+          </a:solidFill>
+          <a:ln>
+            <a:noFill/>
+          </a:ln>
+          <a:effectLst/>
+        </p:spPr>
+        <p:style>
+          <a:lnRef idx="1">
+            <a:schemeClr val="accent1"/>
+          </a:lnRef>
+          <a:fillRef idx="3">
+            <a:schemeClr val="accent1"/>
+          </a:fillRef>
+          <a:effectRef idx="2">
+            <a:schemeClr val="accent1"/>
+          </a:effectRef>
+          <a:fontRef idx="minor">
+            <a:schemeClr val="lt1"/>
+          </a:fontRef>
+        </p:style>
+        <p:txBody>
+          <a:bodyPr rtlCol="0" anchor="ctr"/>
+          <a:lstStyle/>
+          <a:p>
+            <a:pPr algn="ctr"/>
+          </a:p>
+        </p:txBody>
+      </p:sp>
+      <p:sp>
+        <p:nvSpPr>
+          <p:cNvPr id="57" name="TextBox 56"/>
+          <p:cNvSpPr txBox="1"/>
+          <p:nvPr/>
+        </p:nvSpPr>
+        <p:spPr>
+          <a:xfrm>
+            <a:off x="9217152" y="3246120"/>
+            <a:ext cx="2651760" cy="347472"/>
+          </a:xfrm>
+          <a:prstGeom prst="rect">
+            <a:avLst/>
+          </a:prstGeom>
+          <a:noFill/>
+        </p:spPr>
+        <p:txBody>
+          <a:bodyPr wrap="square">
+            <a:spAutoFit/>
+          </a:bodyPr>
+          <a:lstStyle/>
+          <a:p>
+            <a:pPr algn="l"/>
+            <a:r>
+              <a:rPr sz="1300" b="1">
+                <a:solidFill>
+                  <a:srgbClr val="003C6E"/>
+                </a:solidFill>
+              </a:rPr>
+              <a:t>🐳  Container Configs</a:t>
+            </a:r>
+          </a:p>
+        </p:txBody>
+      </p:sp>
+      <p:sp>
+        <p:nvSpPr>
+          <p:cNvPr id="58" name="TextBox 57"/>
+          <p:cNvSpPr txBox="1"/>
+          <p:nvPr/>
+        </p:nvSpPr>
+        <p:spPr>
+          <a:xfrm>
+            <a:off x="9217152" y="3566160"/>
+            <a:ext cx="2651760" cy="320040"/>
+          </a:xfrm>
+          <a:prstGeom prst="rect">
+            <a:avLst/>
+          </a:prstGeom>
+          <a:noFill/>
+        </p:spPr>
+        <p:txBody>
+          <a:bodyPr wrap="square">
+            <a:spAutoFit/>
+          </a:bodyPr>
+          <a:lstStyle/>
+          <a:p>
+            <a:pPr algn="l"/>
+            <a:r>
+              <a:rPr sz="1100" b="0">
+                <a:solidFill>
+                  <a:srgbClr val="2C3E50"/>
+                </a:solidFill>
+              </a:rPr>
+              <a:t>Docker / K8s / Helm</a:t>
+            </a:r>
+          </a:p>
+        </p:txBody>
+      </p:sp>
+      <p:sp>
+        <p:nvSpPr>
+          <p:cNvPr id="59" name="Rounded Rectangle 58"/>
+          <p:cNvSpPr/>
+          <p:nvPr/>
+        </p:nvSpPr>
+        <p:spPr>
+          <a:xfrm>
+            <a:off x="9052560" y="4160520"/>
+            <a:ext cx="109728" cy="640080"/>
+          </a:xfrm>
+          <a:prstGeom prst="roundRect">
+            <a:avLst/>
+          </a:prstGeom>
+          <a:solidFill>
+            <a:srgbClr val="003C6E"/>
+          </a:solidFill>
+          <a:ln>
+            <a:noFill/>
+          </a:ln>
+          <a:effectLst/>
+        </p:spPr>
+        <p:style>
+          <a:lnRef idx="1">
+            <a:schemeClr val="accent1"/>
+          </a:lnRef>
+          <a:fillRef idx="3">
+            <a:schemeClr val="accent1"/>
+          </a:fillRef>
+          <a:effectRef idx="2">
+            <a:schemeClr val="accent1"/>
+          </a:effectRef>
+          <a:fontRef idx="minor">
+            <a:schemeClr val="lt1"/>
+          </a:fontRef>
+        </p:style>
+        <p:txBody>
+          <a:bodyPr rtlCol="0" anchor="ctr"/>
+          <a:lstStyle/>
+          <a:p>
+            <a:pPr algn="ctr"/>
+          </a:p>
+        </p:txBody>
+      </p:sp>
+      <p:sp>
+        <p:nvSpPr>
+          <p:cNvPr id="60" name="TextBox 59"/>
+          <p:cNvSpPr txBox="1"/>
+          <p:nvPr/>
+        </p:nvSpPr>
+        <p:spPr>
+          <a:xfrm>
+            <a:off x="9217152" y="4160520"/>
+            <a:ext cx="2651760" cy="347472"/>
+          </a:xfrm>
+          <a:prstGeom prst="rect">
+            <a:avLst/>
+          </a:prstGeom>
+          <a:noFill/>
+        </p:spPr>
+        <p:txBody>
+          <a:bodyPr wrap="square">
+            <a:spAutoFit/>
+          </a:bodyPr>
+          <a:lstStyle/>
+          <a:p>
+            <a:pPr algn="l"/>
+            <a:r>
+              <a:rPr sz="1300" b="1">
+                <a:solidFill>
+                  <a:srgbClr val="003C6E"/>
+                </a:solidFill>
+              </a:rPr>
+              <a:t>🧠  ML Pipelines</a:t>
+            </a:r>
+          </a:p>
+        </p:txBody>
+      </p:sp>
+      <p:sp>
+        <p:nvSpPr>
+          <p:cNvPr id="61" name="TextBox 60"/>
+          <p:cNvSpPr txBox="1"/>
+          <p:nvPr/>
+        </p:nvSpPr>
+        <p:spPr>
+          <a:xfrm>
+            <a:off x="9217152" y="4480560"/>
+            <a:ext cx="2651760" cy="320040"/>
+          </a:xfrm>
+          <a:prstGeom prst="rect">
+            <a:avLst/>
+          </a:prstGeom>
+          <a:noFill/>
+        </p:spPr>
+        <p:txBody>
+          <a:bodyPr wrap="square">
+            <a:spAutoFit/>
+          </a:bodyPr>
+          <a:lstStyle/>
+          <a:p>
+            <a:pPr algn="l"/>
+            <a:r>
+              <a:rPr sz="1100" b="0">
+                <a:solidFill>
+                  <a:srgbClr val="2C3E50"/>
+                </a:solidFill>
+              </a:rPr>
+              <a:t>Feature Store / MLflow</a:t>
+            </a:r>
+          </a:p>
+        </p:txBody>
+      </p:sp>
+      <p:sp>
+        <p:nvSpPr>
+          <p:cNvPr id="62" name="Rounded Rectangle 61"/>
+          <p:cNvSpPr/>
+          <p:nvPr/>
+        </p:nvSpPr>
+        <p:spPr>
+          <a:xfrm>
+            <a:off x="9052560" y="5074920"/>
+            <a:ext cx="109728" cy="640080"/>
+          </a:xfrm>
+          <a:prstGeom prst="roundRect">
+            <a:avLst/>
+          </a:prstGeom>
+          <a:solidFill>
+            <a:srgbClr val="FF4500"/>
+          </a:solidFill>
+          <a:ln>
+            <a:noFill/>
+          </a:ln>
+          <a:effectLst/>
+        </p:spPr>
+        <p:style>
+          <a:lnRef idx="1">
+            <a:schemeClr val="accent1"/>
+          </a:lnRef>
+          <a:fillRef idx="3">
+            <a:schemeClr val="accent1"/>
+          </a:fillRef>
+          <a:effectRef idx="2">
+            <a:schemeClr val="accent1"/>
+          </a:effectRef>
+          <a:fontRef idx="minor">
+            <a:schemeClr val="lt1"/>
+          </a:fontRef>
+        </p:style>
+        <p:txBody>
+          <a:bodyPr rtlCol="0" anchor="ctr"/>
+          <a:lstStyle/>
+          <a:p>
+            <a:pPr algn="ctr"/>
+          </a:p>
+        </p:txBody>
+      </p:sp>
+      <p:sp>
+        <p:nvSpPr>
+          <p:cNvPr id="63" name="TextBox 62"/>
+          <p:cNvSpPr txBox="1"/>
+          <p:nvPr/>
+        </p:nvSpPr>
+        <p:spPr>
+          <a:xfrm>
+            <a:off x="9217152" y="5074920"/>
+            <a:ext cx="2651760" cy="347472"/>
+          </a:xfrm>
+          <a:prstGeom prst="rect">
+            <a:avLst/>
+          </a:prstGeom>
+          <a:noFill/>
+        </p:spPr>
+        <p:txBody>
+          <a:bodyPr wrap="square">
+            <a:spAutoFit/>
+          </a:bodyPr>
+          <a:lstStyle/>
+          <a:p>
+            <a:pPr algn="l"/>
+            <a:r>
+              <a:rPr sz="1300" b="1">
+                <a:solidFill>
+                  <a:srgbClr val="003C6E"/>
+                </a:solidFill>
+              </a:rPr>
+              <a:t>💰  Cost Reports</a:t>
+            </a:r>
+          </a:p>
+        </p:txBody>
+      </p:sp>
+      <p:sp>
+        <p:nvSpPr>
+          <p:cNvPr id="64" name="TextBox 63"/>
+          <p:cNvSpPr txBox="1"/>
+          <p:nvPr/>
+        </p:nvSpPr>
+        <p:spPr>
+          <a:xfrm>
+            <a:off x="9217152" y="5394960"/>
+            <a:ext cx="2651760" cy="320040"/>
+          </a:xfrm>
+          <a:prstGeom prst="rect">
+            <a:avLst/>
+          </a:prstGeom>
+          <a:noFill/>
+        </p:spPr>
+        <p:txBody>
+          <a:bodyPr wrap="square">
+            <a:spAutoFit/>
+          </a:bodyPr>
+          <a:lstStyle/>
+          <a:p>
+            <a:pPr algn="l"/>
+            <a:r>
+              <a:rPr sz="1100" b="0">
+                <a:solidFill>
+                  <a:srgbClr val="2C3E50"/>
+                </a:solidFill>
+              </a:rPr>
+              <a:t>TCO / DBU estimates</a:t>
+            </a:r>
+          </a:p>
+        </p:txBody>
+      </p:sp>
+      <p:sp>
+        <p:nvSpPr>
+          <p:cNvPr id="65" name="TextBox 64"/>
+          <p:cNvSpPr txBox="1"/>
+          <p:nvPr/>
+        </p:nvSpPr>
+        <p:spPr>
+          <a:xfrm>
+            <a:off x="274320" y="6126480"/>
+            <a:ext cx="11430000" cy="457200"/>
+          </a:xfrm>
+          <a:prstGeom prst="rect">
+            <a:avLst/>
+          </a:prstGeom>
+          <a:noFill/>
+        </p:spPr>
+        <p:txBody>
+          <a:bodyPr wrap="square">
+            <a:spAutoFit/>
+          </a:bodyPr>
+          <a:lstStyle/>
+          <a:p>
+            <a:pPr algn="ctr"/>
+            <a:r>
+              <a:rPr sz="1200" b="0">
+                <a:solidFill>
+                  <a:srgbClr val="95A5A6"/>
+                </a:solidFill>
+              </a:rPr>
+              <a:t>CLI:  informatica-to-fabric --target fabric | databricks | dbt | auto    •    Python SDK:  MigrationSDK.migrate()    •    REST API:  POST /migrate</a:t>
             </a:r>
           </a:p>
         </p:txBody>

</xml_diff>